<commit_message>
Deploy Benchback on Firebase with guarded voice inspection and durable workspaces
</commit_message>
<xml_diff>
--- a/submission/benchback-pitch.pptx
+++ b/submission/benchback-pitch.pptx
@@ -2,21 +2,21 @@
 <file path=ppt/presentation.xml><?xml version="1.0" encoding="utf-8"?>
 <p:presentation xmlns:p="http://schemas.openxmlformats.org/presentationml/2006/main">
   <p:sldMasterIdLst>
-    <p:sldMasterId xmlns:r="http://schemas.openxmlformats.org/officeDocument/2006/relationships" id="2147483648" r:id="R16504715bb444950"/>
+    <p:sldMasterId xmlns:r="http://schemas.openxmlformats.org/officeDocument/2006/relationships" id="2147483648" r:id="Rdf31378e76da47a8"/>
   </p:sldMasterIdLst>
   <p:notesMasterIdLst>
-    <p:notesMasterId xmlns:r="http://schemas.openxmlformats.org/officeDocument/2006/relationships" r:id="R836ca24c1194430e"/>
+    <p:notesMasterId xmlns:r="http://schemas.openxmlformats.org/officeDocument/2006/relationships" r:id="R5b623df05bdd412b"/>
   </p:notesMasterIdLst>
   <p:sldIdLst>
-    <p:sldId xmlns:r="http://schemas.openxmlformats.org/officeDocument/2006/relationships" id="256" r:id="R981566d721bd408d"/>
-    <p:sldId xmlns:r="http://schemas.openxmlformats.org/officeDocument/2006/relationships" id="257" r:id="R2c14b5c710894b99"/>
-    <p:sldId xmlns:r="http://schemas.openxmlformats.org/officeDocument/2006/relationships" id="258" r:id="R7dc870e77c1948e5"/>
-    <p:sldId xmlns:r="http://schemas.openxmlformats.org/officeDocument/2006/relationships" id="259" r:id="Rf5051f32ba984585"/>
-    <p:sldId xmlns:r="http://schemas.openxmlformats.org/officeDocument/2006/relationships" id="260" r:id="Ra6ab037445484a40"/>
-    <p:sldId xmlns:r="http://schemas.openxmlformats.org/officeDocument/2006/relationships" id="261" r:id="R7d7fd7548009435d"/>
-    <p:sldId xmlns:r="http://schemas.openxmlformats.org/officeDocument/2006/relationships" id="262" r:id="Redf07e5993e040b4"/>
-    <p:sldId xmlns:r="http://schemas.openxmlformats.org/officeDocument/2006/relationships" id="263" r:id="Rcda6e8a22e9d4b36"/>
-    <p:sldId xmlns:r="http://schemas.openxmlformats.org/officeDocument/2006/relationships" id="264" r:id="R8783a03cb1004037"/>
+    <p:sldId xmlns:r="http://schemas.openxmlformats.org/officeDocument/2006/relationships" id="256" r:id="R186db360da8c46b1"/>
+    <p:sldId xmlns:r="http://schemas.openxmlformats.org/officeDocument/2006/relationships" id="257" r:id="R88d819155ac64682"/>
+    <p:sldId xmlns:r="http://schemas.openxmlformats.org/officeDocument/2006/relationships" id="258" r:id="R9a6211c8ce814dd2"/>
+    <p:sldId xmlns:r="http://schemas.openxmlformats.org/officeDocument/2006/relationships" id="259" r:id="R51830a3e4cde4ad8"/>
+    <p:sldId xmlns:r="http://schemas.openxmlformats.org/officeDocument/2006/relationships" id="260" r:id="Re118baa2cd324090"/>
+    <p:sldId xmlns:r="http://schemas.openxmlformats.org/officeDocument/2006/relationships" id="261" r:id="R89e6889647254d43"/>
+    <p:sldId xmlns:r="http://schemas.openxmlformats.org/officeDocument/2006/relationships" id="262" r:id="Rbeafb27a6da5422c"/>
+    <p:sldId xmlns:r="http://schemas.openxmlformats.org/officeDocument/2006/relationships" id="263" r:id="R6f4fd6b1007d4dc7"/>
+    <p:sldId xmlns:r="http://schemas.openxmlformats.org/officeDocument/2006/relationships" id="264" r:id="R2a400205c6a846be"/>
   </p:sldIdLst>
   <p:sldSz cx="12192000" cy="6858000"/>
   <p:notesSz cx="6858000" cy="9144000"/>
@@ -610,7 +610,7 @@
           <a:lstStyle xmlns:a="http://schemas.openxmlformats.org/drawingml/2006/main"/>
           <a:p xmlns:a="http://schemas.openxmlformats.org/drawingml/2006/main">
             <a:r>
-              <a:t>In our fictional demo, a technician finds alternator ALT-24-160 with a 240-dollar core deposit. Benchback matches work order 418 and invoice 8042. The original box is gone. The configured supplier policy permits an alternate container, but the technician must confirm the part is complete before the manager reviews the return pack. Shipment on July 23 gives a September 21 deadline under the configured sixty-calendar-day rule.</a:t>
+              <a:t>In our fictional demo, a technician finds alternator ALT-24-160 with a 240-dollar core deposit. Benchback matches work order 418 and invoice 8042. The original box is gone. The configured supplier policy permits an alternate container, but the technician must confirm the part is complete before the manager reviews the return pack. The practice example begins four days before its configured deadline. Benchback calculates that deadline from the purchase date and the stored supplier rule.</a:t>
             </a:r>
           </a:p>
           <a:p xmlns:a="http://schemas.openxmlformats.org/drawingml/2006/main">
@@ -625,7 +625,7 @@
           </a:p>
           <a:p xmlns:a="http://schemas.openxmlformats.org/drawingml/2006/main">
             <a:r>
-              <a:t>Demo data is fictional. Shipment date: 23 July 2026. Configured return deadline: 21 September 2026. Supplier policies vary. FleetPride publishes a 60-day window from shipment and original packaging OR a quality container placed on a pallet: https://www.fleetpride.com/help/returnwarranty</a:t>
+              <a:t>Demo data is fictional. Practice dates move with the demo date. Supplier policies vary. FleetPride publishes a 60-day window from shipment and original packaging OR a quality container placed on a pallet: https://www.fleetpride.com/help/returnwarranty</a:t>
             </a:r>
           </a:p>
         </p:txBody>
@@ -695,7 +695,7 @@
           <a:lstStyle xmlns:a="http://schemas.openxmlformats.org/drawingml/2006/main"/>
           <a:p xmlns:a="http://schemas.openxmlformats.org/drawingml/2006/main">
             <a:r>
-              <a:t>Voice is the interface because the technician is handling a dirty part. AssemblyAI’s native Voice Agent API combines speech recognition, reasoning, speech output, and tool calls. Benchback adds the business controls. Tools match evidence, apply the shop’s approved supplier policy, require manager review, and reconcile posted credits. This is the intended architecture. End-to-end live voice behavior still requires validation.</a:t>
+              <a:t>Voice is the interface because the technician is handling a dirty part. AssemblyAI’s native Voice Agent API combines speech recognition, reasoning, speech output, and tool calls. Benchback adds the business controls. Tools match evidence, apply the shop’s approved supplier policy, require manager review, and reconcile posted credits. The agent may record inspection evidence and follow-up notes. Only the signed-in operator can approve a return or change its credit ledger.</a:t>
             </a:r>
           </a:p>
           <a:p xmlns:a="http://schemas.openxmlformats.org/drawingml/2006/main">
@@ -715,7 +715,7 @@
           </a:p>
           <a:p xmlns:a="http://schemas.openxmlformats.org/drawingml/2006/main">
             <a:r>
-              <a:t>Technical design description, not a claim of completed live integration testing.</a:t>
+              <a:t>Next.js 16 and React 19 serve the application on Cloud Run. Firebase Hosting supplies the public URL. Firebase Authentication identifies the operator, and Firestore stores isolated workspaces. Secrets remain on the server.</a:t>
             </a:r>
           </a:p>
         </p:txBody>
@@ -875,7 +875,7 @@
           <a:lstStyle xmlns:a="http://schemas.openxmlformats.org/drawingml/2006/main"/>
           <a:p xmlns:a="http://schemas.openxmlformats.org/drawingml/2006/main">
             <a:r>
-              <a:t>The product follows both people involved. The technician collects evidence through voice or forms. The parts manager reviews the return pack, records dispatch, and reconciles supplier credits. Account login, an isolated durable workspace, imports and exports, history, and policy configuration support that process. These are product capabilities and implementation scope, not tested production guarantees.</a:t>
+              <a:t>The product follows both people involved. The technician collects evidence through voice or forms. The parts manager reviews the return pack, records dispatch, and reconciles supplier credits. Account login, an isolated durable workspace, imports and exports, history, and policy configuration support that process. Firebase Authentication and server-side ownership checks isolate each workspace. Firestore transactions protect revisions and credit allocation. Downloadable PDF packs preserve the evidence needed for review. The deployed application is available at https://benchback-ai.web.app.</a:t>
             </a:r>
           </a:p>
         </p:txBody>
@@ -945,7 +945,7 @@
           <a:lstStyle xmlns:a="http://schemas.openxmlformats.org/drawingml/2006/main"/>
           <a:p xmlns:a="http://schemas.openxmlformats.org/drawingml/2006/main">
             <a:r>
-              <a:t>The direct buyer is the independent diesel shop owner or parts manager. Our starting price hypothesis is 99 dollars per location per month, including 200 voice minutes. At AssemblyAI’s published 7.5 cents per minute, those minutes cost fifteen dollars before hosting, support, or other operating costs. Pricing and willingness to pay still need pilot evidence.</a:t>
+              <a:t>The direct buyer is the independent diesel shop owner or parts manager. Our starting price hypothesis is 99 dollars per location per month, including 200 voice minutes. At AssemblyAI’s published 7.5 cents per minute, those minutes cost fifteen dollars before hosting, Firestore usage, support, or other operating costs. Pricing and willingness to pay still need pilot evidence.</a:t>
             </a:r>
           </a:p>
           <a:p xmlns:a="http://schemas.openxmlformats.org/drawingml/2006/main">
@@ -1125,7 +1125,7 @@
           <a:lstStyle xmlns:a="http://schemas.openxmlformats.org/drawingml/2006/main"/>
           <a:p xmlns:a="http://schemas.openxmlformats.org/drawingml/2006/main">
             <a:r>
-              <a:t>Our next step is a small pilot with independent diesel shops. We will validate their actual supplier policies, follow alternator and starter returns, and reconcile the resulting credit memos. Success means received credits with an explainable audit trail. We will also test voice reliability, adoption, and willingness to pay. Benchback brings the money already paid back into view.</a:t>
+              <a:t>Our next step is a small pilot with independent diesel shops. We will validate their actual supplier policies, follow alternator and starter returns, and reconcile the resulting credit memos. Success means received credits with an explainable audit trail. We will compare voice against a short form and each shop’s current workflow, counting setup and CSV import work. We will test voice reliability, adoption, and willingness to pay. Benchback brings the money already paid back into view.</a:t>
             </a:r>
           </a:p>
           <a:p xmlns:a="http://schemas.openxmlformats.org/drawingml/2006/main">
@@ -1208,7 +1208,7 @@
   </p:cSld>
   <p:clrMap bg1="lt1" tx1="dk1" bg2="lt2" tx2="dk2" accent1="accent1" accent2="accent2" accent3="accent3" accent4="accent4" accent5="accent5" accent6="accent6" hlink="hlink" folHlink="folHlink"/>
   <p:sldLayoutIdLst>
-    <p:sldLayoutId xmlns:r="http://schemas.openxmlformats.org/officeDocument/2006/relationships" id="2147483649" r:id="Rd28099d205934aa4"/>
+    <p:sldLayoutId xmlns:r="http://schemas.openxmlformats.org/officeDocument/2006/relationships" id="2147483649" r:id="Rd3a316b00c6e400f"/>
   </p:sldLayoutIdLst>
   <p:txStyles>
     <p:titleStyle>
@@ -1756,10 +1756,10 @@
       </p:grpSpPr>
       <p:sp>
         <p:nvSpPr>
-          <p:cNvPr id="6" name="">
-            <a:extLst xmlns:a="http://schemas.openxmlformats.org/drawingml/2006/main">
-              <a:ext uri="{FF2B5EF4-FFF2-40B4-BE49-F238E27FC236}">
-                <a16:creationId xmlns:a16="http://schemas.microsoft.com/office/drawing/2014/main" id="{735DD8D5-1303-415D-88C6-34D3299BD8C6}"/>
+          <p:cNvPr id="7" name="">
+            <a:extLst xmlns:a="http://schemas.openxmlformats.org/drawingml/2006/main">
+              <a:ext uri="{FF2B5EF4-FFF2-40B4-BE49-F238E27FC236}">
+                <a16:creationId xmlns:a16="http://schemas.microsoft.com/office/drawing/2014/main" id="{4FEAB14E-4CB5-4649-B86A-BF98CF187AF5}"/>
               </a:ext>
             </a:extLst>
           </p:cNvPr>
@@ -1816,7 +1816,7 @@
           <p:cNvPr id="2" name="">
             <a:extLst xmlns:a="http://schemas.openxmlformats.org/drawingml/2006/main">
               <a:ext uri="{FF2B5EF4-FFF2-40B4-BE49-F238E27FC236}">
-                <a16:creationId xmlns:a16="http://schemas.microsoft.com/office/drawing/2014/main" id="{CCDCB4B9-A87A-4155-AE67-8407D98071AC}"/>
+                <a16:creationId xmlns:a16="http://schemas.microsoft.com/office/drawing/2014/main" id="{5480524A-E218-478C-BD81-E5C85AEE6206}"/>
               </a:ext>
             </a:extLst>
           </p:cNvPr>
@@ -1873,7 +1873,7 @@
           <p:cNvPr id="3" name="">
             <a:extLst xmlns:a="http://schemas.openxmlformats.org/drawingml/2006/main">
               <a:ext uri="{FF2B5EF4-FFF2-40B4-BE49-F238E27FC236}">
-                <a16:creationId xmlns:a16="http://schemas.microsoft.com/office/drawing/2014/main" id="{B3744012-1E65-446A-B3ED-E3CA2C5F6CE1}"/>
+                <a16:creationId xmlns:a16="http://schemas.microsoft.com/office/drawing/2014/main" id="{169B5287-A440-4EB5-9743-C0735576C935}"/>
               </a:ext>
             </a:extLst>
           </p:cNvPr>
@@ -1953,7 +1953,7 @@
           <p:cNvPr id="4" name="">
             <a:extLst xmlns:a="http://schemas.openxmlformats.org/drawingml/2006/main">
               <a:ext uri="{FF2B5EF4-FFF2-40B4-BE49-F238E27FC236}">
-                <a16:creationId xmlns:a16="http://schemas.microsoft.com/office/drawing/2014/main" id="{FB79F546-878A-4E6F-88E6-693A2E2AB667}"/>
+                <a16:creationId xmlns:a16="http://schemas.microsoft.com/office/drawing/2014/main" id="{B3A0CA18-4DCC-48ED-9BC2-6AAA434FA7FC}"/>
               </a:ext>
             </a:extLst>
           </p:cNvPr>
@@ -2010,7 +2010,7 @@
           <p:cNvPr id="5" name="">
             <a:extLst xmlns:a="http://schemas.openxmlformats.org/drawingml/2006/main">
               <a:ext uri="{FF2B5EF4-FFF2-40B4-BE49-F238E27FC236}">
-                <a16:creationId xmlns:a16="http://schemas.microsoft.com/office/drawing/2014/main" id="{98CB58B3-9E39-4B88-B91C-B176C8C2BA53}"/>
+                <a16:creationId xmlns:a16="http://schemas.microsoft.com/office/drawing/2014/main" id="{CBA9F3D9-D57A-4C92-8804-F3309C9C0692}"/>
               </a:ext>
             </a:extLst>
           </p:cNvPr>
@@ -2022,7 +2022,7 @@
         <p:spPr>
           <a:xfrm xmlns:a="http://schemas.openxmlformats.org/drawingml/2006/main">
             <a:off x="609600" y="6057900"/>
-            <a:ext cx="7620000" cy="304800"/>
+            <a:ext cx="5048250" cy="304800"/>
           </a:xfrm>
           <a:prstGeom xmlns:a="http://schemas.openxmlformats.org/drawingml/2006/main" prst="rect">
             <a:avLst/>
@@ -2057,7 +2057,64 @@
                 <a:ea typeface="Arial"/>
                 <a:cs typeface="Arial"/>
               </a:rPr>
-              <a:t>Shivam Gupta</a:t>
+              <a:t>Created by Shivam Gupta</a:t>
+            </a:r>
+          </a:p>
+        </p:txBody>
+      </p:sp>
+      <p:sp>
+        <p:nvSpPr>
+          <p:cNvPr id="6" name="">
+            <a:extLst xmlns:a="http://schemas.openxmlformats.org/drawingml/2006/main">
+              <a:ext uri="{FF2B5EF4-FFF2-40B4-BE49-F238E27FC236}">
+                <a16:creationId xmlns:a16="http://schemas.microsoft.com/office/drawing/2014/main" id="{8742E542-DC0E-4743-8661-A02A7C885B63}"/>
+              </a:ext>
+            </a:extLst>
+          </p:cNvPr>
+          <p:cNvSpPr>
+            <a:spLocks xmlns:a="http://schemas.openxmlformats.org/drawingml/2006/main" noGrp="1"/>
+          </p:cNvSpPr>
+          <p:nvPr/>
+        </p:nvSpPr>
+        <p:spPr>
+          <a:xfrm xmlns:a="http://schemas.openxmlformats.org/drawingml/2006/main">
+            <a:off x="6858000" y="6057900"/>
+            <a:ext cx="4572000" cy="304800"/>
+          </a:xfrm>
+          <a:prstGeom xmlns:a="http://schemas.openxmlformats.org/drawingml/2006/main" prst="rect">
+            <a:avLst/>
+          </a:prstGeom>
+          <a:noFill xmlns:a="http://schemas.openxmlformats.org/drawingml/2006/main"/>
+          <a:ln xmlns:a="http://schemas.openxmlformats.org/drawingml/2006/main" w="0">
+            <a:noFill/>
+          </a:ln>
+        </p:spPr>
+        <p:txBody>
+          <a:bodyPr xmlns:a="http://schemas.openxmlformats.org/drawingml/2006/main">
+            <a:noAutofit/>
+          </a:bodyPr>
+          <a:lstStyle xmlns:a="http://schemas.openxmlformats.org/drawingml/2006/main"/>
+          <a:p xmlns:a="http://schemas.openxmlformats.org/drawingml/2006/main">
+            <a:pPr>
+              <a:defRPr sz="1725" b="1">
+                <a:solidFill>
+                  <a:srgbClr val="C5EF69"/>
+                </a:solidFill>
+                <a:latin typeface="Arial"/>
+                <a:ea typeface="Arial"/>
+                <a:cs typeface="Arial"/>
+              </a:defRPr>
+            </a:pPr>
+            <a:r>
+              <a:rPr sz="1725" b="1">
+                <a:solidFill>
+                  <a:srgbClr val="C5EF69"/>
+                </a:solidFill>
+                <a:latin typeface="Arial"/>
+                <a:ea typeface="Arial"/>
+                <a:cs typeface="Arial"/>
+              </a:rPr>
+              <a:t>benchback-ai.web.app</a:t>
             </a:r>
           </a:p>
         </p:txBody>
@@ -2065,7 +2122,7 @@
     </p:spTree>
     <p:extLst>
       <p:ext uri="{BB962C8B-B14F-4D97-AF65-F5344CB8AC3E}">
-        <p14:creationId xmlns:p14="http://schemas.microsoft.com/office/powerpoint/2010/main" val="84554305"/>
+        <p14:creationId xmlns:p14="http://schemas.microsoft.com/office/powerpoint/2010/main" val="2113070631"/>
       </p:ext>
     </p:extLst>
   </p:cSld>
@@ -2096,7 +2153,7 @@
           <p:cNvPr id="20" name="">
             <a:extLst xmlns:a="http://schemas.openxmlformats.org/drawingml/2006/main">
               <a:ext uri="{FF2B5EF4-FFF2-40B4-BE49-F238E27FC236}">
-                <a16:creationId xmlns:a16="http://schemas.microsoft.com/office/drawing/2014/main" id="{3871FF7B-613F-43BE-A38F-D8EB5FEE3BB5}"/>
+                <a16:creationId xmlns:a16="http://schemas.microsoft.com/office/drawing/2014/main" id="{58D951E0-F088-4B12-A09F-1EAB4F4E7050}"/>
               </a:ext>
             </a:extLst>
           </p:cNvPr>
@@ -2153,7 +2210,7 @@
           <p:cNvPr id="2" name="">
             <a:extLst xmlns:a="http://schemas.openxmlformats.org/drawingml/2006/main">
               <a:ext uri="{FF2B5EF4-FFF2-40B4-BE49-F238E27FC236}">
-                <a16:creationId xmlns:a16="http://schemas.microsoft.com/office/drawing/2014/main" id="{ACBF3C82-616A-4F40-A48A-3498575096BB}"/>
+                <a16:creationId xmlns:a16="http://schemas.microsoft.com/office/drawing/2014/main" id="{30255A63-8A9F-4B11-8AF5-BB669ADB50A8}"/>
               </a:ext>
             </a:extLst>
           </p:cNvPr>
@@ -2210,7 +2267,7 @@
           <p:cNvPr id="3" name="">
             <a:extLst xmlns:a="http://schemas.openxmlformats.org/drawingml/2006/main">
               <a:ext uri="{FF2B5EF4-FFF2-40B4-BE49-F238E27FC236}">
-                <a16:creationId xmlns:a16="http://schemas.microsoft.com/office/drawing/2014/main" id="{D09C8800-80C4-4248-9666-833CA00D94B8}"/>
+                <a16:creationId xmlns:a16="http://schemas.microsoft.com/office/drawing/2014/main" id="{655CB8AA-69A5-459A-9D89-FDAE9DF56DA3}"/>
               </a:ext>
             </a:extLst>
           </p:cNvPr>
@@ -2267,7 +2324,7 @@
           <p:cNvPr id="4" name="">
             <a:extLst xmlns:a="http://schemas.openxmlformats.org/drawingml/2006/main">
               <a:ext uri="{FF2B5EF4-FFF2-40B4-BE49-F238E27FC236}">
-                <a16:creationId xmlns:a16="http://schemas.microsoft.com/office/drawing/2014/main" id="{63920609-FD19-4BC8-95D9-B122DF12C363}"/>
+                <a16:creationId xmlns:a16="http://schemas.microsoft.com/office/drawing/2014/main" id="{C3AF0BFD-E772-49E7-8946-22DE946B93A6}"/>
               </a:ext>
             </a:extLst>
           </p:cNvPr>
@@ -2324,7 +2381,7 @@
           <p:cNvPr id="5" name="">
             <a:extLst xmlns:a="http://schemas.openxmlformats.org/drawingml/2006/main">
               <a:ext uri="{FF2B5EF4-FFF2-40B4-BE49-F238E27FC236}">
-                <a16:creationId xmlns:a16="http://schemas.microsoft.com/office/drawing/2014/main" id="{37EED69F-D1D9-4891-902D-A3071F812B31}"/>
+                <a16:creationId xmlns:a16="http://schemas.microsoft.com/office/drawing/2014/main" id="{FC15B046-86CC-4314-AAA0-BEB3C812E09F}"/>
               </a:ext>
             </a:extLst>
           </p:cNvPr>
@@ -2381,7 +2438,7 @@
           <p:cNvPr id="6" name="">
             <a:extLst xmlns:a="http://schemas.openxmlformats.org/drawingml/2006/main">
               <a:ext uri="{FF2B5EF4-FFF2-40B4-BE49-F238E27FC236}">
-                <a16:creationId xmlns:a16="http://schemas.microsoft.com/office/drawing/2014/main" id="{FF5F1232-86AB-438B-AE34-84BA826CB505}"/>
+                <a16:creationId xmlns:a16="http://schemas.microsoft.com/office/drawing/2014/main" id="{BBFB85CA-9225-4A9E-B367-3DA928AC9AF9}"/>
               </a:ext>
             </a:extLst>
           </p:cNvPr>
@@ -2438,7 +2495,7 @@
           <p:cNvPr id="7" name="">
             <a:extLst xmlns:a="http://schemas.openxmlformats.org/drawingml/2006/main">
               <a:ext uri="{FF2B5EF4-FFF2-40B4-BE49-F238E27FC236}">
-                <a16:creationId xmlns:a16="http://schemas.microsoft.com/office/drawing/2014/main" id="{F3836483-11B9-425F-8C35-B356D721F4F2}"/>
+                <a16:creationId xmlns:a16="http://schemas.microsoft.com/office/drawing/2014/main" id="{83478B17-3D0F-4F14-AE13-9FE11B41647E}"/>
               </a:ext>
             </a:extLst>
           </p:cNvPr>
@@ -2470,7 +2527,7 @@
           <p:cNvPr id="8" name="">
             <a:extLst xmlns:a="http://schemas.openxmlformats.org/drawingml/2006/main">
               <a:ext uri="{FF2B5EF4-FFF2-40B4-BE49-F238E27FC236}">
-                <a16:creationId xmlns:a16="http://schemas.microsoft.com/office/drawing/2014/main" id="{9FB02CE4-6CBD-48B1-9D48-F3CD9867A014}"/>
+                <a16:creationId xmlns:a16="http://schemas.microsoft.com/office/drawing/2014/main" id="{5349F292-47F0-41E7-AD85-3F343ACB6F1B}"/>
               </a:ext>
             </a:extLst>
           </p:cNvPr>
@@ -2527,7 +2584,7 @@
           <p:cNvPr id="9" name="">
             <a:extLst xmlns:a="http://schemas.openxmlformats.org/drawingml/2006/main">
               <a:ext uri="{FF2B5EF4-FFF2-40B4-BE49-F238E27FC236}">
-                <a16:creationId xmlns:a16="http://schemas.microsoft.com/office/drawing/2014/main" id="{F547A93B-8331-4046-B83F-C4DD366013F7}"/>
+                <a16:creationId xmlns:a16="http://schemas.microsoft.com/office/drawing/2014/main" id="{43D12817-CA3B-4B1B-807A-FA8138D455D2}"/>
               </a:ext>
             </a:extLst>
           </p:cNvPr>
@@ -2584,7 +2641,7 @@
           <p:cNvPr id="10" name="">
             <a:extLst xmlns:a="http://schemas.openxmlformats.org/drawingml/2006/main">
               <a:ext uri="{FF2B5EF4-FFF2-40B4-BE49-F238E27FC236}">
-                <a16:creationId xmlns:a16="http://schemas.microsoft.com/office/drawing/2014/main" id="{8B15FEE7-F4D6-4C78-8A14-6327490879F4}"/>
+                <a16:creationId xmlns:a16="http://schemas.microsoft.com/office/drawing/2014/main" id="{4D2006E0-66EF-4FB7-A721-D6DE3BB10BFD}"/>
               </a:ext>
             </a:extLst>
           </p:cNvPr>
@@ -2641,7 +2698,7 @@
           <p:cNvPr id="11" name="">
             <a:extLst xmlns:a="http://schemas.openxmlformats.org/drawingml/2006/main">
               <a:ext uri="{FF2B5EF4-FFF2-40B4-BE49-F238E27FC236}">
-                <a16:creationId xmlns:a16="http://schemas.microsoft.com/office/drawing/2014/main" id="{46738BAA-F026-42B5-89EB-73E166E9B97A}"/>
+                <a16:creationId xmlns:a16="http://schemas.microsoft.com/office/drawing/2014/main" id="{010DA811-E6E3-44CD-ABB6-C0384B65B450}"/>
               </a:ext>
             </a:extLst>
           </p:cNvPr>
@@ -2673,7 +2730,7 @@
           <p:cNvPr id="12" name="">
             <a:extLst xmlns:a="http://schemas.openxmlformats.org/drawingml/2006/main">
               <a:ext uri="{FF2B5EF4-FFF2-40B4-BE49-F238E27FC236}">
-                <a16:creationId xmlns:a16="http://schemas.microsoft.com/office/drawing/2014/main" id="{78965366-D133-4D28-AC01-CCF3416F7D24}"/>
+                <a16:creationId xmlns:a16="http://schemas.microsoft.com/office/drawing/2014/main" id="{CBED74ED-7C45-4F57-A412-9B9ED5F135F3}"/>
               </a:ext>
             </a:extLst>
           </p:cNvPr>
@@ -2730,7 +2787,7 @@
           <p:cNvPr id="13" name="">
             <a:extLst xmlns:a="http://schemas.openxmlformats.org/drawingml/2006/main">
               <a:ext uri="{FF2B5EF4-FFF2-40B4-BE49-F238E27FC236}">
-                <a16:creationId xmlns:a16="http://schemas.microsoft.com/office/drawing/2014/main" id="{67B33522-4BF0-4AAA-8439-BDF5C1E17715}"/>
+                <a16:creationId xmlns:a16="http://schemas.microsoft.com/office/drawing/2014/main" id="{0A3450B9-3FAA-4436-8A65-364F18553D5E}"/>
               </a:ext>
             </a:extLst>
           </p:cNvPr>
@@ -2787,7 +2844,7 @@
           <p:cNvPr id="14" name="">
             <a:extLst xmlns:a="http://schemas.openxmlformats.org/drawingml/2006/main">
               <a:ext uri="{FF2B5EF4-FFF2-40B4-BE49-F238E27FC236}">
-                <a16:creationId xmlns:a16="http://schemas.microsoft.com/office/drawing/2014/main" id="{E6CEAAA3-9574-4775-B954-0D4428490A88}"/>
+                <a16:creationId xmlns:a16="http://schemas.microsoft.com/office/drawing/2014/main" id="{39490F65-5EA7-4266-B399-8C949C41736B}"/>
               </a:ext>
             </a:extLst>
           </p:cNvPr>
@@ -2844,7 +2901,7 @@
           <p:cNvPr id="15" name="">
             <a:extLst xmlns:a="http://schemas.openxmlformats.org/drawingml/2006/main">
               <a:ext uri="{FF2B5EF4-FFF2-40B4-BE49-F238E27FC236}">
-                <a16:creationId xmlns:a16="http://schemas.microsoft.com/office/drawing/2014/main" id="{5867A9FA-DFB9-4E5C-B93F-723C1D8D85F4}"/>
+                <a16:creationId xmlns:a16="http://schemas.microsoft.com/office/drawing/2014/main" id="{CDEAA4B1-0CF4-4408-B06B-CD335252149E}"/>
               </a:ext>
             </a:extLst>
           </p:cNvPr>
@@ -2876,7 +2933,7 @@
           <p:cNvPr id="16" name="">
             <a:extLst xmlns:a="http://schemas.openxmlformats.org/drawingml/2006/main">
               <a:ext uri="{FF2B5EF4-FFF2-40B4-BE49-F238E27FC236}">
-                <a16:creationId xmlns:a16="http://schemas.microsoft.com/office/drawing/2014/main" id="{02BCD1D8-ADDB-41B1-948C-C47687B0E342}"/>
+                <a16:creationId xmlns:a16="http://schemas.microsoft.com/office/drawing/2014/main" id="{77069A82-7C45-449F-A565-D56AB6F6F5AE}"/>
               </a:ext>
             </a:extLst>
           </p:cNvPr>
@@ -2933,7 +2990,7 @@
           <p:cNvPr id="17" name="">
             <a:extLst xmlns:a="http://schemas.openxmlformats.org/drawingml/2006/main">
               <a:ext uri="{FF2B5EF4-FFF2-40B4-BE49-F238E27FC236}">
-                <a16:creationId xmlns:a16="http://schemas.microsoft.com/office/drawing/2014/main" id="{76EDAD0F-D4E9-407E-9FB7-716D2D4D95F8}"/>
+                <a16:creationId xmlns:a16="http://schemas.microsoft.com/office/drawing/2014/main" id="{F502ACD5-A411-446D-B980-3829050A56DA}"/>
               </a:ext>
             </a:extLst>
           </p:cNvPr>
@@ -2990,7 +3047,7 @@
           <p:cNvPr id="18" name="">
             <a:extLst xmlns:a="http://schemas.openxmlformats.org/drawingml/2006/main">
               <a:ext uri="{FF2B5EF4-FFF2-40B4-BE49-F238E27FC236}">
-                <a16:creationId xmlns:a16="http://schemas.microsoft.com/office/drawing/2014/main" id="{3B5C092B-DEE7-4B11-A60D-327C50CE0831}"/>
+                <a16:creationId xmlns:a16="http://schemas.microsoft.com/office/drawing/2014/main" id="{06FD0E6F-9683-4405-A8C2-EDFD4E955C5A}"/>
               </a:ext>
             </a:extLst>
           </p:cNvPr>
@@ -3047,7 +3104,7 @@
           <p:cNvPr id="19" name="">
             <a:extLst xmlns:a="http://schemas.openxmlformats.org/drawingml/2006/main">
               <a:ext uri="{FF2B5EF4-FFF2-40B4-BE49-F238E27FC236}">
-                <a16:creationId xmlns:a16="http://schemas.microsoft.com/office/drawing/2014/main" id="{9B5F143C-5B94-4BAA-83C3-FE3BE6185004}"/>
+                <a16:creationId xmlns:a16="http://schemas.microsoft.com/office/drawing/2014/main" id="{3E8E0ADA-856B-4F3F-AB88-BE11DEEFCA2F}"/>
               </a:ext>
             </a:extLst>
           </p:cNvPr>
@@ -3102,7 +3159,7 @@
     </p:spTree>
     <p:extLst>
       <p:ext uri="{BB962C8B-B14F-4D97-AF65-F5344CB8AC3E}">
-        <p14:creationId xmlns:p14="http://schemas.microsoft.com/office/powerpoint/2010/main" val="1804683120"/>
+        <p14:creationId xmlns:p14="http://schemas.microsoft.com/office/powerpoint/2010/main" val="1355562734"/>
       </p:ext>
     </p:extLst>
   </p:cSld>
@@ -3133,7 +3190,7 @@
           <p:cNvPr id="17" name="">
             <a:extLst xmlns:a="http://schemas.openxmlformats.org/drawingml/2006/main">
               <a:ext uri="{FF2B5EF4-FFF2-40B4-BE49-F238E27FC236}">
-                <a16:creationId xmlns:a16="http://schemas.microsoft.com/office/drawing/2014/main" id="{7F8F50C5-ECA3-42EE-9780-EACD64237715}"/>
+                <a16:creationId xmlns:a16="http://schemas.microsoft.com/office/drawing/2014/main" id="{69AF8562-A4E5-4AC5-8158-4EDF1EF928D6}"/>
               </a:ext>
             </a:extLst>
           </p:cNvPr>
@@ -3190,7 +3247,7 @@
           <p:cNvPr id="2" name="">
             <a:extLst xmlns:a="http://schemas.openxmlformats.org/drawingml/2006/main">
               <a:ext uri="{FF2B5EF4-FFF2-40B4-BE49-F238E27FC236}">
-                <a16:creationId xmlns:a16="http://schemas.microsoft.com/office/drawing/2014/main" id="{F1590EC1-85F8-4B35-BD3A-69D8F2DF211F}"/>
+                <a16:creationId xmlns:a16="http://schemas.microsoft.com/office/drawing/2014/main" id="{037A4F35-D8CC-42AF-881C-EB7669C37FC3}"/>
               </a:ext>
             </a:extLst>
           </p:cNvPr>
@@ -3247,7 +3304,7 @@
           <p:cNvPr id="3" name="">
             <a:extLst xmlns:a="http://schemas.openxmlformats.org/drawingml/2006/main">
               <a:ext uri="{FF2B5EF4-FFF2-40B4-BE49-F238E27FC236}">
-                <a16:creationId xmlns:a16="http://schemas.microsoft.com/office/drawing/2014/main" id="{1ED1491C-0437-464F-886F-186B6AB49E72}"/>
+                <a16:creationId xmlns:a16="http://schemas.microsoft.com/office/drawing/2014/main" id="{55FDE21B-1D03-41D8-9AAC-4CBFC522A1C2}"/>
               </a:ext>
             </a:extLst>
           </p:cNvPr>
@@ -3304,7 +3361,7 @@
           <p:cNvPr id="4" name="">
             <a:extLst xmlns:a="http://schemas.openxmlformats.org/drawingml/2006/main">
               <a:ext uri="{FF2B5EF4-FFF2-40B4-BE49-F238E27FC236}">
-                <a16:creationId xmlns:a16="http://schemas.microsoft.com/office/drawing/2014/main" id="{E9E2698A-3F2E-4571-8DA0-0E2770A49742}"/>
+                <a16:creationId xmlns:a16="http://schemas.microsoft.com/office/drawing/2014/main" id="{2A9503BB-DC90-48EB-8915-5EDA494FB8A2}"/>
               </a:ext>
             </a:extLst>
           </p:cNvPr>
@@ -3361,7 +3418,7 @@
           <p:cNvPr id="5" name="">
             <a:extLst xmlns:a="http://schemas.openxmlformats.org/drawingml/2006/main">
               <a:ext uri="{FF2B5EF4-FFF2-40B4-BE49-F238E27FC236}">
-                <a16:creationId xmlns:a16="http://schemas.microsoft.com/office/drawing/2014/main" id="{643CDADC-4032-4709-933A-6995BCD6466A}"/>
+                <a16:creationId xmlns:a16="http://schemas.microsoft.com/office/drawing/2014/main" id="{BEABD5CF-29CF-4BE0-9B85-E1A44DEF4D88}"/>
               </a:ext>
             </a:extLst>
           </p:cNvPr>
@@ -3418,7 +3475,7 @@
           <p:cNvPr id="6" name="">
             <a:extLst xmlns:a="http://schemas.openxmlformats.org/drawingml/2006/main">
               <a:ext uri="{FF2B5EF4-FFF2-40B4-BE49-F238E27FC236}">
-                <a16:creationId xmlns:a16="http://schemas.microsoft.com/office/drawing/2014/main" id="{9906537A-4D09-43FD-8EC4-066903A17D38}"/>
+                <a16:creationId xmlns:a16="http://schemas.microsoft.com/office/drawing/2014/main" id="{2D16588E-1E6C-4515-A4A3-0846EBB25545}"/>
               </a:ext>
             </a:extLst>
           </p:cNvPr>
@@ -3475,7 +3532,7 @@
           <p:cNvPr id="7" name="">
             <a:extLst xmlns:a="http://schemas.openxmlformats.org/drawingml/2006/main">
               <a:ext uri="{FF2B5EF4-FFF2-40B4-BE49-F238E27FC236}">
-                <a16:creationId xmlns:a16="http://schemas.microsoft.com/office/drawing/2014/main" id="{CF433B3F-1757-43E7-BA1A-63423F68B543}"/>
+                <a16:creationId xmlns:a16="http://schemas.microsoft.com/office/drawing/2014/main" id="{BB2EE303-58DF-4A68-808C-AA13078BD5DF}"/>
               </a:ext>
             </a:extLst>
           </p:cNvPr>
@@ -3532,7 +3589,7 @@
           <p:cNvPr id="8" name="">
             <a:extLst xmlns:a="http://schemas.openxmlformats.org/drawingml/2006/main">
               <a:ext uri="{FF2B5EF4-FFF2-40B4-BE49-F238E27FC236}">
-                <a16:creationId xmlns:a16="http://schemas.microsoft.com/office/drawing/2014/main" id="{08A5188A-9734-4712-BF86-722BDA02A189}"/>
+                <a16:creationId xmlns:a16="http://schemas.microsoft.com/office/drawing/2014/main" id="{DB8330DF-D1D8-4CBF-80B2-39BA14998529}"/>
               </a:ext>
             </a:extLst>
           </p:cNvPr>
@@ -3564,7 +3621,7 @@
           <p:cNvPr id="9" name="">
             <a:extLst xmlns:a="http://schemas.openxmlformats.org/drawingml/2006/main">
               <a:ext uri="{FF2B5EF4-FFF2-40B4-BE49-F238E27FC236}">
-                <a16:creationId xmlns:a16="http://schemas.microsoft.com/office/drawing/2014/main" id="{B28F89B3-E41B-4937-A189-7C79FEEEF908}"/>
+                <a16:creationId xmlns:a16="http://schemas.microsoft.com/office/drawing/2014/main" id="{8A6D1355-1C0F-4AFD-9EC1-8E68C11E8D00}"/>
               </a:ext>
             </a:extLst>
           </p:cNvPr>
@@ -3621,7 +3678,7 @@
           <p:cNvPr id="10" name="">
             <a:extLst xmlns:a="http://schemas.openxmlformats.org/drawingml/2006/main">
               <a:ext uri="{FF2B5EF4-FFF2-40B4-BE49-F238E27FC236}">
-                <a16:creationId xmlns:a16="http://schemas.microsoft.com/office/drawing/2014/main" id="{102569C4-B868-47AC-9730-620D71442BE5}"/>
+                <a16:creationId xmlns:a16="http://schemas.microsoft.com/office/drawing/2014/main" id="{072C8B45-5F56-471F-8E2D-2BDDD3E08A4B}"/>
               </a:ext>
             </a:extLst>
           </p:cNvPr>
@@ -3678,7 +3735,7 @@
           <p:cNvPr id="11" name="">
             <a:extLst xmlns:a="http://schemas.openxmlformats.org/drawingml/2006/main">
               <a:ext uri="{FF2B5EF4-FFF2-40B4-BE49-F238E27FC236}">
-                <a16:creationId xmlns:a16="http://schemas.microsoft.com/office/drawing/2014/main" id="{F8F1E6D5-85F0-4734-9327-C04D28444A9B}"/>
+                <a16:creationId xmlns:a16="http://schemas.microsoft.com/office/drawing/2014/main" id="{E0EE7ACE-F957-447D-BFE5-9537A133F530}"/>
               </a:ext>
             </a:extLst>
           </p:cNvPr>
@@ -3710,7 +3767,7 @@
           <p:cNvPr id="12" name="">
             <a:extLst xmlns:a="http://schemas.openxmlformats.org/drawingml/2006/main">
               <a:ext uri="{FF2B5EF4-FFF2-40B4-BE49-F238E27FC236}">
-                <a16:creationId xmlns:a16="http://schemas.microsoft.com/office/drawing/2014/main" id="{68848473-809B-472E-ADE1-5DE3B7BADE68}"/>
+                <a16:creationId xmlns:a16="http://schemas.microsoft.com/office/drawing/2014/main" id="{A1786AB2-922B-458B-A55A-4A016732AB3D}"/>
               </a:ext>
             </a:extLst>
           </p:cNvPr>
@@ -3767,7 +3824,7 @@
           <p:cNvPr id="13" name="">
             <a:extLst xmlns:a="http://schemas.openxmlformats.org/drawingml/2006/main">
               <a:ext uri="{FF2B5EF4-FFF2-40B4-BE49-F238E27FC236}">
-                <a16:creationId xmlns:a16="http://schemas.microsoft.com/office/drawing/2014/main" id="{6E793CD1-11B9-4465-955A-D7A7C27AA589}"/>
+                <a16:creationId xmlns:a16="http://schemas.microsoft.com/office/drawing/2014/main" id="{19ED5BC7-7CA5-45C6-A8C8-FB9C113FDACC}"/>
               </a:ext>
             </a:extLst>
           </p:cNvPr>
@@ -3814,7 +3871,7 @@
                 <a:ea typeface="Arial"/>
                 <a:cs typeface="Arial"/>
               </a:rPr>
-              <a:t>21 Sep 2026</a:t>
+              <a:t>4 days left in this example</a:t>
             </a:r>
           </a:p>
         </p:txBody>
@@ -3824,7 +3881,7 @@
           <p:cNvPr id="14" name="">
             <a:extLst xmlns:a="http://schemas.openxmlformats.org/drawingml/2006/main">
               <a:ext uri="{FF2B5EF4-FFF2-40B4-BE49-F238E27FC236}">
-                <a16:creationId xmlns:a16="http://schemas.microsoft.com/office/drawing/2014/main" id="{0CEDC9C5-C998-4975-BB19-BCD0A7F8F832}"/>
+                <a16:creationId xmlns:a16="http://schemas.microsoft.com/office/drawing/2014/main" id="{43DBD9EA-F5B4-47A2-9E98-03958FEC77C9}"/>
               </a:ext>
             </a:extLst>
           </p:cNvPr>
@@ -3856,7 +3913,7 @@
           <p:cNvPr id="15" name="">
             <a:extLst xmlns:a="http://schemas.openxmlformats.org/drawingml/2006/main">
               <a:ext uri="{FF2B5EF4-FFF2-40B4-BE49-F238E27FC236}">
-                <a16:creationId xmlns:a16="http://schemas.microsoft.com/office/drawing/2014/main" id="{DC107FDE-2D96-4005-999A-BB1F4E6B897A}"/>
+                <a16:creationId xmlns:a16="http://schemas.microsoft.com/office/drawing/2014/main" id="{5B8A6A0D-DB96-4E0F-B099-75F995007825}"/>
               </a:ext>
             </a:extLst>
           </p:cNvPr>
@@ -3913,7 +3970,7 @@
           <p:cNvPr id="16" name="">
             <a:extLst xmlns:a="http://schemas.openxmlformats.org/drawingml/2006/main">
               <a:ext uri="{FF2B5EF4-FFF2-40B4-BE49-F238E27FC236}">
-                <a16:creationId xmlns:a16="http://schemas.microsoft.com/office/drawing/2014/main" id="{DF80902C-9DED-4F81-B59F-916FBE433B27}"/>
+                <a16:creationId xmlns:a16="http://schemas.microsoft.com/office/drawing/2014/main" id="{4C486BDB-3956-463B-B148-87ED73E40C6C}"/>
               </a:ext>
             </a:extLst>
           </p:cNvPr>
@@ -3968,7 +4025,7 @@
     </p:spTree>
     <p:extLst>
       <p:ext uri="{BB962C8B-B14F-4D97-AF65-F5344CB8AC3E}">
-        <p14:creationId xmlns:p14="http://schemas.microsoft.com/office/powerpoint/2010/main" val="449876456"/>
+        <p14:creationId xmlns:p14="http://schemas.microsoft.com/office/powerpoint/2010/main" val="1235381192"/>
       </p:ext>
     </p:extLst>
   </p:cSld>
@@ -3999,7 +4056,7 @@
           <p:cNvPr id="21" name="">
             <a:extLst xmlns:a="http://schemas.openxmlformats.org/drawingml/2006/main">
               <a:ext uri="{FF2B5EF4-FFF2-40B4-BE49-F238E27FC236}">
-                <a16:creationId xmlns:a16="http://schemas.microsoft.com/office/drawing/2014/main" id="{408FD00A-D7B3-416A-9C65-DC599E83A5DE}"/>
+                <a16:creationId xmlns:a16="http://schemas.microsoft.com/office/drawing/2014/main" id="{81647A61-9421-4E9F-8FD2-067654B6337C}"/>
               </a:ext>
             </a:extLst>
           </p:cNvPr>
@@ -4056,7 +4113,7 @@
           <p:cNvPr id="2" name="">
             <a:extLst xmlns:a="http://schemas.openxmlformats.org/drawingml/2006/main">
               <a:ext uri="{FF2B5EF4-FFF2-40B4-BE49-F238E27FC236}">
-                <a16:creationId xmlns:a16="http://schemas.microsoft.com/office/drawing/2014/main" id="{6D7091A9-AC27-4A9F-8DAB-5CA4420986D0}"/>
+                <a16:creationId xmlns:a16="http://schemas.microsoft.com/office/drawing/2014/main" id="{3B1E5006-89F3-4B1C-A8CC-88BF82CFB109}"/>
               </a:ext>
             </a:extLst>
           </p:cNvPr>
@@ -4113,7 +4170,7 @@
           <p:cNvPr id="3" name="">
             <a:extLst xmlns:a="http://schemas.openxmlformats.org/drawingml/2006/main">
               <a:ext uri="{FF2B5EF4-FFF2-40B4-BE49-F238E27FC236}">
-                <a16:creationId xmlns:a16="http://schemas.microsoft.com/office/drawing/2014/main" id="{B6A9C24E-048D-4DA8-A8C8-4DF0B396179D}"/>
+                <a16:creationId xmlns:a16="http://schemas.microsoft.com/office/drawing/2014/main" id="{3AD694D7-A88F-4940-A2FF-30C8DA6A107D}"/>
               </a:ext>
             </a:extLst>
           </p:cNvPr>
@@ -4170,7 +4227,7 @@
           <p:cNvPr id="4" name="">
             <a:extLst xmlns:a="http://schemas.openxmlformats.org/drawingml/2006/main">
               <a:ext uri="{FF2B5EF4-FFF2-40B4-BE49-F238E27FC236}">
-                <a16:creationId xmlns:a16="http://schemas.microsoft.com/office/drawing/2014/main" id="{06ECD03F-0091-40C4-BABD-6B87D1C2AB1A}"/>
+                <a16:creationId xmlns:a16="http://schemas.microsoft.com/office/drawing/2014/main" id="{DC7B7BEA-F5A9-4705-A26A-3897CC7505CF}"/>
               </a:ext>
             </a:extLst>
           </p:cNvPr>
@@ -4227,7 +4284,7 @@
           <p:cNvPr id="5" name="">
             <a:extLst xmlns:a="http://schemas.openxmlformats.org/drawingml/2006/main">
               <a:ext uri="{FF2B5EF4-FFF2-40B4-BE49-F238E27FC236}">
-                <a16:creationId xmlns:a16="http://schemas.microsoft.com/office/drawing/2014/main" id="{9B7A4495-FBC1-4A15-900E-DBD1C1476601}"/>
+                <a16:creationId xmlns:a16="http://schemas.microsoft.com/office/drawing/2014/main" id="{D1E16A28-4CF1-4D8B-AADA-323CEC6F8F63}"/>
               </a:ext>
             </a:extLst>
           </p:cNvPr>
@@ -4259,7 +4316,7 @@
           <p:cNvPr id="6" name="">
             <a:extLst xmlns:a="http://schemas.openxmlformats.org/drawingml/2006/main">
               <a:ext uri="{FF2B5EF4-FFF2-40B4-BE49-F238E27FC236}">
-                <a16:creationId xmlns:a16="http://schemas.microsoft.com/office/drawing/2014/main" id="{CE19C8D0-C075-463F-BCD4-67EBB91B37FA}"/>
+                <a16:creationId xmlns:a16="http://schemas.microsoft.com/office/drawing/2014/main" id="{0A925A8B-F0CF-427F-B2A5-5B7690352F07}"/>
               </a:ext>
             </a:extLst>
           </p:cNvPr>
@@ -4316,7 +4373,7 @@
           <p:cNvPr id="7" name="">
             <a:extLst xmlns:a="http://schemas.openxmlformats.org/drawingml/2006/main">
               <a:ext uri="{FF2B5EF4-FFF2-40B4-BE49-F238E27FC236}">
-                <a16:creationId xmlns:a16="http://schemas.microsoft.com/office/drawing/2014/main" id="{F42043DE-1F65-48B0-AC91-0B3AD1DBE0CB}"/>
+                <a16:creationId xmlns:a16="http://schemas.microsoft.com/office/drawing/2014/main" id="{73A2F86D-F3B4-4E9C-984B-A8B5D90A6D21}"/>
               </a:ext>
             </a:extLst>
           </p:cNvPr>
@@ -4363,7 +4420,7 @@
                 <a:ea typeface="Arial"/>
                 <a:cs typeface="Arial"/>
               </a:rPr>
-              <a:t>Invoice, job and part evidence</a:t>
+              <a:t>Invoice, job, part and purchase line</a:t>
             </a:r>
           </a:p>
         </p:txBody>
@@ -4373,7 +4430,7 @@
           <p:cNvPr id="8" name="">
             <a:extLst xmlns:a="http://schemas.openxmlformats.org/drawingml/2006/main">
               <a:ext uri="{FF2B5EF4-FFF2-40B4-BE49-F238E27FC236}">
-                <a16:creationId xmlns:a16="http://schemas.microsoft.com/office/drawing/2014/main" id="{2A8D7A79-FCD2-4C6E-85B5-6E2CF6EC6339}"/>
+                <a16:creationId xmlns:a16="http://schemas.microsoft.com/office/drawing/2014/main" id="{74CDA197-A3E4-45C0-96BD-ED0AC7ECE589}"/>
               </a:ext>
             </a:extLst>
           </p:cNvPr>
@@ -4405,7 +4462,7 @@
           <p:cNvPr id="9" name="">
             <a:extLst xmlns:a="http://schemas.openxmlformats.org/drawingml/2006/main">
               <a:ext uri="{FF2B5EF4-FFF2-40B4-BE49-F238E27FC236}">
-                <a16:creationId xmlns:a16="http://schemas.microsoft.com/office/drawing/2014/main" id="{69D97FCA-AD8F-4FB8-8951-E3B92684F80D}"/>
+                <a16:creationId xmlns:a16="http://schemas.microsoft.com/office/drawing/2014/main" id="{FE49A3E9-FAC6-4448-98F5-77CFB3BAC79F}"/>
               </a:ext>
             </a:extLst>
           </p:cNvPr>
@@ -4437,7 +4494,7 @@
           <p:cNvPr id="10" name="">
             <a:extLst xmlns:a="http://schemas.openxmlformats.org/drawingml/2006/main">
               <a:ext uri="{FF2B5EF4-FFF2-40B4-BE49-F238E27FC236}">
-                <a16:creationId xmlns:a16="http://schemas.microsoft.com/office/drawing/2014/main" id="{EF3F2802-25A0-4B93-B6DE-364C29C18C85}"/>
+                <a16:creationId xmlns:a16="http://schemas.microsoft.com/office/drawing/2014/main" id="{5153677B-60A0-4304-B97A-8A8B370B9A3A}"/>
               </a:ext>
             </a:extLst>
           </p:cNvPr>
@@ -4494,7 +4551,7 @@
           <p:cNvPr id="11" name="">
             <a:extLst xmlns:a="http://schemas.openxmlformats.org/drawingml/2006/main">
               <a:ext uri="{FF2B5EF4-FFF2-40B4-BE49-F238E27FC236}">
-                <a16:creationId xmlns:a16="http://schemas.microsoft.com/office/drawing/2014/main" id="{5BD1B4E4-EAEA-4079-8016-553604D5664B}"/>
+                <a16:creationId xmlns:a16="http://schemas.microsoft.com/office/drawing/2014/main" id="{5FBAAADA-3719-40A7-B76F-37A114DD674A}"/>
               </a:ext>
             </a:extLst>
           </p:cNvPr>
@@ -4551,7 +4608,7 @@
           <p:cNvPr id="12" name="">
             <a:extLst xmlns:a="http://schemas.openxmlformats.org/drawingml/2006/main">
               <a:ext uri="{FF2B5EF4-FFF2-40B4-BE49-F238E27FC236}">
-                <a16:creationId xmlns:a16="http://schemas.microsoft.com/office/drawing/2014/main" id="{22320684-612C-442F-AFB5-A439214A56E5}"/>
+                <a16:creationId xmlns:a16="http://schemas.microsoft.com/office/drawing/2014/main" id="{541FEA48-105A-4D5F-B077-D2B0884B04B4}"/>
               </a:ext>
             </a:extLst>
           </p:cNvPr>
@@ -4583,7 +4640,7 @@
           <p:cNvPr id="13" name="">
             <a:extLst xmlns:a="http://schemas.openxmlformats.org/drawingml/2006/main">
               <a:ext uri="{FF2B5EF4-FFF2-40B4-BE49-F238E27FC236}">
-                <a16:creationId xmlns:a16="http://schemas.microsoft.com/office/drawing/2014/main" id="{968A4D87-70F3-446D-917B-5C43CD89550F}"/>
+                <a16:creationId xmlns:a16="http://schemas.microsoft.com/office/drawing/2014/main" id="{F85E9629-D847-4CFC-BB4D-A9F8C8477B52}"/>
               </a:ext>
             </a:extLst>
           </p:cNvPr>
@@ -4615,7 +4672,7 @@
           <p:cNvPr id="14" name="">
             <a:extLst xmlns:a="http://schemas.openxmlformats.org/drawingml/2006/main">
               <a:ext uri="{FF2B5EF4-FFF2-40B4-BE49-F238E27FC236}">
-                <a16:creationId xmlns:a16="http://schemas.microsoft.com/office/drawing/2014/main" id="{01763C71-9F30-4E2E-AD4B-0A70A5D15E36}"/>
+                <a16:creationId xmlns:a16="http://schemas.microsoft.com/office/drawing/2014/main" id="{C2E9A80D-F4B9-4A45-93F4-858EAE5A72AC}"/>
               </a:ext>
             </a:extLst>
           </p:cNvPr>
@@ -4672,7 +4729,7 @@
           <p:cNvPr id="15" name="">
             <a:extLst xmlns:a="http://schemas.openxmlformats.org/drawingml/2006/main">
               <a:ext uri="{FF2B5EF4-FFF2-40B4-BE49-F238E27FC236}">
-                <a16:creationId xmlns:a16="http://schemas.microsoft.com/office/drawing/2014/main" id="{E4C99AE3-F16F-41E0-B49C-9A19A55BA854}"/>
+                <a16:creationId xmlns:a16="http://schemas.microsoft.com/office/drawing/2014/main" id="{24B401CF-0B32-4E21-9845-CB35249D39F7}"/>
               </a:ext>
             </a:extLst>
           </p:cNvPr>
@@ -4729,7 +4786,7 @@
           <p:cNvPr id="16" name="">
             <a:extLst xmlns:a="http://schemas.openxmlformats.org/drawingml/2006/main">
               <a:ext uri="{FF2B5EF4-FFF2-40B4-BE49-F238E27FC236}">
-                <a16:creationId xmlns:a16="http://schemas.microsoft.com/office/drawing/2014/main" id="{DBCB4282-62F4-454B-983B-BBFFAA514070}"/>
+                <a16:creationId xmlns:a16="http://schemas.microsoft.com/office/drawing/2014/main" id="{EA4C5F52-62E0-4D7E-A955-BBC29F4A3FFA}"/>
               </a:ext>
             </a:extLst>
           </p:cNvPr>
@@ -4761,7 +4818,7 @@
           <p:cNvPr id="17" name="">
             <a:extLst xmlns:a="http://schemas.openxmlformats.org/drawingml/2006/main">
               <a:ext uri="{FF2B5EF4-FFF2-40B4-BE49-F238E27FC236}">
-                <a16:creationId xmlns:a16="http://schemas.microsoft.com/office/drawing/2014/main" id="{C9E1461D-B590-4F9A-AF19-74D98671160A}"/>
+                <a16:creationId xmlns:a16="http://schemas.microsoft.com/office/drawing/2014/main" id="{461000C9-6C52-4F4E-8C28-CD6DE56F1124}"/>
               </a:ext>
             </a:extLst>
           </p:cNvPr>
@@ -4793,7 +4850,7 @@
           <p:cNvPr id="18" name="">
             <a:extLst xmlns:a="http://schemas.openxmlformats.org/drawingml/2006/main">
               <a:ext uri="{FF2B5EF4-FFF2-40B4-BE49-F238E27FC236}">
-                <a16:creationId xmlns:a16="http://schemas.microsoft.com/office/drawing/2014/main" id="{ABDB7C2F-6EC8-4539-BAED-3565CCD54BDA}"/>
+                <a16:creationId xmlns:a16="http://schemas.microsoft.com/office/drawing/2014/main" id="{9A130029-DE15-428E-BF14-034903B9FA57}"/>
               </a:ext>
             </a:extLst>
           </p:cNvPr>
@@ -4850,7 +4907,7 @@
           <p:cNvPr id="19" name="">
             <a:extLst xmlns:a="http://schemas.openxmlformats.org/drawingml/2006/main">
               <a:ext uri="{FF2B5EF4-FFF2-40B4-BE49-F238E27FC236}">
-                <a16:creationId xmlns:a16="http://schemas.microsoft.com/office/drawing/2014/main" id="{AFC7251F-5FC7-4570-8F85-3355B092364C}"/>
+                <a16:creationId xmlns:a16="http://schemas.microsoft.com/office/drawing/2014/main" id="{C695A8F4-09BD-49A0-9C50-80262FAF7934}"/>
               </a:ext>
             </a:extLst>
           </p:cNvPr>
@@ -4907,7 +4964,7 @@
           <p:cNvPr id="20" name="">
             <a:extLst xmlns:a="http://schemas.openxmlformats.org/drawingml/2006/main">
               <a:ext uri="{FF2B5EF4-FFF2-40B4-BE49-F238E27FC236}">
-                <a16:creationId xmlns:a16="http://schemas.microsoft.com/office/drawing/2014/main" id="{1B499F5F-BF8A-426E-B266-CCBF56CC3923}"/>
+                <a16:creationId xmlns:a16="http://schemas.microsoft.com/office/drawing/2014/main" id="{2D3BCDAB-5031-4F07-8319-2B630A268B54}"/>
               </a:ext>
             </a:extLst>
           </p:cNvPr>
@@ -4962,7 +5019,7 @@
     </p:spTree>
     <p:extLst>
       <p:ext uri="{BB962C8B-B14F-4D97-AF65-F5344CB8AC3E}">
-        <p14:creationId xmlns:p14="http://schemas.microsoft.com/office/powerpoint/2010/main" val="1752479281"/>
+        <p14:creationId xmlns:p14="http://schemas.microsoft.com/office/powerpoint/2010/main" val="163255585"/>
       </p:ext>
     </p:extLst>
   </p:cSld>
@@ -4993,7 +5050,7 @@
           <p:cNvPr id="15" name="">
             <a:extLst xmlns:a="http://schemas.openxmlformats.org/drawingml/2006/main">
               <a:ext uri="{FF2B5EF4-FFF2-40B4-BE49-F238E27FC236}">
-                <a16:creationId xmlns:a16="http://schemas.microsoft.com/office/drawing/2014/main" id="{5BEC8721-0CB8-448C-A59B-5BF03993A9D1}"/>
+                <a16:creationId xmlns:a16="http://schemas.microsoft.com/office/drawing/2014/main" id="{0FB0AE96-2070-4865-833B-5F6A7DD8F146}"/>
               </a:ext>
             </a:extLst>
           </p:cNvPr>
@@ -5050,7 +5107,7 @@
           <p:cNvPr id="2" name="">
             <a:extLst xmlns:a="http://schemas.openxmlformats.org/drawingml/2006/main">
               <a:ext uri="{FF2B5EF4-FFF2-40B4-BE49-F238E27FC236}">
-                <a16:creationId xmlns:a16="http://schemas.microsoft.com/office/drawing/2014/main" id="{9990727C-B907-4F81-8749-1C419E41CE28}"/>
+                <a16:creationId xmlns:a16="http://schemas.microsoft.com/office/drawing/2014/main" id="{6F1AE440-89D2-406F-B593-9A9AC76BF439}"/>
               </a:ext>
             </a:extLst>
           </p:cNvPr>
@@ -5107,7 +5164,7 @@
           <p:cNvPr id="3" name="">
             <a:extLst xmlns:a="http://schemas.openxmlformats.org/drawingml/2006/main">
               <a:ext uri="{FF2B5EF4-FFF2-40B4-BE49-F238E27FC236}">
-                <a16:creationId xmlns:a16="http://schemas.microsoft.com/office/drawing/2014/main" id="{6E5D470C-D711-4791-AE34-043FBD6154C7}"/>
+                <a16:creationId xmlns:a16="http://schemas.microsoft.com/office/drawing/2014/main" id="{2839E349-D39A-45B6-820C-41B87ABD880B}"/>
               </a:ext>
             </a:extLst>
           </p:cNvPr>
@@ -5164,7 +5221,7 @@
           <p:cNvPr id="4" name="">
             <a:extLst xmlns:a="http://schemas.openxmlformats.org/drawingml/2006/main">
               <a:ext uri="{FF2B5EF4-FFF2-40B4-BE49-F238E27FC236}">
-                <a16:creationId xmlns:a16="http://schemas.microsoft.com/office/drawing/2014/main" id="{1091189E-B9F4-429F-B5E5-ED2B4206886E}"/>
+                <a16:creationId xmlns:a16="http://schemas.microsoft.com/office/drawing/2014/main" id="{71CB0AA7-DD32-4CEA-8418-479D762DAC3B}"/>
               </a:ext>
             </a:extLst>
           </p:cNvPr>
@@ -5221,7 +5278,7 @@
           <p:cNvPr id="5" name="">
             <a:extLst xmlns:a="http://schemas.openxmlformats.org/drawingml/2006/main">
               <a:ext uri="{FF2B5EF4-FFF2-40B4-BE49-F238E27FC236}">
-                <a16:creationId xmlns:a16="http://schemas.microsoft.com/office/drawing/2014/main" id="{0DBC192C-FCCA-49EA-A3CB-F853610CECC0}"/>
+                <a16:creationId xmlns:a16="http://schemas.microsoft.com/office/drawing/2014/main" id="{1D294765-5665-4052-88B8-792C8D7F62A0}"/>
               </a:ext>
             </a:extLst>
           </p:cNvPr>
@@ -5278,7 +5335,7 @@
           <p:cNvPr id="6" name="">
             <a:extLst xmlns:a="http://schemas.openxmlformats.org/drawingml/2006/main">
               <a:ext uri="{FF2B5EF4-FFF2-40B4-BE49-F238E27FC236}">
-                <a16:creationId xmlns:a16="http://schemas.microsoft.com/office/drawing/2014/main" id="{045CEC1C-88F3-467F-A35F-44FB4468FC50}"/>
+                <a16:creationId xmlns:a16="http://schemas.microsoft.com/office/drawing/2014/main" id="{FAE9D0C2-F19F-4113-95E3-435090DB8565}"/>
               </a:ext>
             </a:extLst>
           </p:cNvPr>
@@ -5335,7 +5392,7 @@
           <p:cNvPr id="7" name="">
             <a:extLst xmlns:a="http://schemas.openxmlformats.org/drawingml/2006/main">
               <a:ext uri="{FF2B5EF4-FFF2-40B4-BE49-F238E27FC236}">
-                <a16:creationId xmlns:a16="http://schemas.microsoft.com/office/drawing/2014/main" id="{AD488CF0-CB39-436B-9271-340059F0C0D3}"/>
+                <a16:creationId xmlns:a16="http://schemas.microsoft.com/office/drawing/2014/main" id="{D3E4E27B-E6B4-4929-AED3-692B19B725E8}"/>
               </a:ext>
             </a:extLst>
           </p:cNvPr>
@@ -5392,7 +5449,7 @@
           <p:cNvPr id="8" name="">
             <a:extLst xmlns:a="http://schemas.openxmlformats.org/drawingml/2006/main">
               <a:ext uri="{FF2B5EF4-FFF2-40B4-BE49-F238E27FC236}">
-                <a16:creationId xmlns:a16="http://schemas.microsoft.com/office/drawing/2014/main" id="{8360AE03-B2AD-48B2-9E56-63A0782BE949}"/>
+                <a16:creationId xmlns:a16="http://schemas.microsoft.com/office/drawing/2014/main" id="{1517C792-4037-4C7B-AC9E-15AE895D14EB}"/>
               </a:ext>
             </a:extLst>
           </p:cNvPr>
@@ -5449,7 +5506,7 @@
           <p:cNvPr id="9" name="">
             <a:extLst xmlns:a="http://schemas.openxmlformats.org/drawingml/2006/main">
               <a:ext uri="{FF2B5EF4-FFF2-40B4-BE49-F238E27FC236}">
-                <a16:creationId xmlns:a16="http://schemas.microsoft.com/office/drawing/2014/main" id="{A0BBA2E3-9138-40D3-A8E7-EBF68DBF505E}"/>
+                <a16:creationId xmlns:a16="http://schemas.microsoft.com/office/drawing/2014/main" id="{5DC11EFB-AA8F-4685-8820-9094FB768432}"/>
               </a:ext>
             </a:extLst>
           </p:cNvPr>
@@ -5506,7 +5563,7 @@
           <p:cNvPr id="10" name="">
             <a:extLst xmlns:a="http://schemas.openxmlformats.org/drawingml/2006/main">
               <a:ext uri="{FF2B5EF4-FFF2-40B4-BE49-F238E27FC236}">
-                <a16:creationId xmlns:a16="http://schemas.microsoft.com/office/drawing/2014/main" id="{6C3867C7-43D1-4D4D-AD70-DF57E8B93902}"/>
+                <a16:creationId xmlns:a16="http://schemas.microsoft.com/office/drawing/2014/main" id="{9B54C4DC-ADE7-4864-B5D7-9270AD9C165F}"/>
               </a:ext>
             </a:extLst>
           </p:cNvPr>
@@ -5563,7 +5620,7 @@
           <p:cNvPr id="11" name="">
             <a:extLst xmlns:a="http://schemas.openxmlformats.org/drawingml/2006/main">
               <a:ext uri="{FF2B5EF4-FFF2-40B4-BE49-F238E27FC236}">
-                <a16:creationId xmlns:a16="http://schemas.microsoft.com/office/drawing/2014/main" id="{7E1DD328-BFFD-440A-A98B-DA73D5F4E71E}"/>
+                <a16:creationId xmlns:a16="http://schemas.microsoft.com/office/drawing/2014/main" id="{CD34AE2D-D1B2-4FCA-9A23-1118745C693E}"/>
               </a:ext>
             </a:extLst>
           </p:cNvPr>
@@ -5620,7 +5677,7 @@
           <p:cNvPr id="12" name="">
             <a:extLst xmlns:a="http://schemas.openxmlformats.org/drawingml/2006/main">
               <a:ext uri="{FF2B5EF4-FFF2-40B4-BE49-F238E27FC236}">
-                <a16:creationId xmlns:a16="http://schemas.microsoft.com/office/drawing/2014/main" id="{B2DB7BB4-8A18-4403-AA26-599423791B32}"/>
+                <a16:creationId xmlns:a16="http://schemas.microsoft.com/office/drawing/2014/main" id="{D4D4FA9A-913D-44D6-AC4F-7723C567426E}"/>
               </a:ext>
             </a:extLst>
           </p:cNvPr>
@@ -5677,7 +5734,7 @@
           <p:cNvPr id="13" name="">
             <a:extLst xmlns:a="http://schemas.openxmlformats.org/drawingml/2006/main">
               <a:ext uri="{FF2B5EF4-FFF2-40B4-BE49-F238E27FC236}">
-                <a16:creationId xmlns:a16="http://schemas.microsoft.com/office/drawing/2014/main" id="{B8C30CF7-E574-4A64-AFA1-B3D668EE81BD}"/>
+                <a16:creationId xmlns:a16="http://schemas.microsoft.com/office/drawing/2014/main" id="{46EE859E-B661-41A7-89FA-19745D1F88C4}"/>
               </a:ext>
             </a:extLst>
           </p:cNvPr>
@@ -5709,7 +5766,7 @@
           <p:cNvPr id="14" name="">
             <a:extLst xmlns:a="http://schemas.openxmlformats.org/drawingml/2006/main">
               <a:ext uri="{FF2B5EF4-FFF2-40B4-BE49-F238E27FC236}">
-                <a16:creationId xmlns:a16="http://schemas.microsoft.com/office/drawing/2014/main" id="{DA97C443-245C-4B86-8EA7-942B3C80CDCD}"/>
+                <a16:creationId xmlns:a16="http://schemas.microsoft.com/office/drawing/2014/main" id="{C297F335-FB64-423D-9A17-D3034065EAE1}"/>
               </a:ext>
             </a:extLst>
           </p:cNvPr>
@@ -5764,7 +5821,7 @@
     </p:spTree>
     <p:extLst>
       <p:ext uri="{BB962C8B-B14F-4D97-AF65-F5344CB8AC3E}">
-        <p14:creationId xmlns:p14="http://schemas.microsoft.com/office/powerpoint/2010/main" val="1143613292"/>
+        <p14:creationId xmlns:p14="http://schemas.microsoft.com/office/powerpoint/2010/main" val="955550961"/>
       </p:ext>
     </p:extLst>
   </p:cSld>
@@ -5795,7 +5852,7 @@
           <p:cNvPr id="10" name="">
             <a:extLst xmlns:a="http://schemas.openxmlformats.org/drawingml/2006/main">
               <a:ext uri="{FF2B5EF4-FFF2-40B4-BE49-F238E27FC236}">
-                <a16:creationId xmlns:a16="http://schemas.microsoft.com/office/drawing/2014/main" id="{501CAC14-95AD-42AA-A86D-CAEE197D41F6}"/>
+                <a16:creationId xmlns:a16="http://schemas.microsoft.com/office/drawing/2014/main" id="{11B89E97-5B7F-4B1E-8460-48B76A2C7ABF}"/>
               </a:ext>
             </a:extLst>
           </p:cNvPr>
@@ -5852,7 +5909,7 @@
           <p:cNvPr id="2" name="">
             <a:extLst xmlns:a="http://schemas.openxmlformats.org/drawingml/2006/main">
               <a:ext uri="{FF2B5EF4-FFF2-40B4-BE49-F238E27FC236}">
-                <a16:creationId xmlns:a16="http://schemas.microsoft.com/office/drawing/2014/main" id="{FA5AD93D-18AF-435D-B44A-00C9F634B8C1}"/>
+                <a16:creationId xmlns:a16="http://schemas.microsoft.com/office/drawing/2014/main" id="{70D7245B-5755-4FD7-8A61-385FF38F0094}"/>
               </a:ext>
             </a:extLst>
           </p:cNvPr>
@@ -5909,7 +5966,7 @@
           <p:cNvPr id="3" name="">
             <a:extLst xmlns:a="http://schemas.openxmlformats.org/drawingml/2006/main">
               <a:ext uri="{FF2B5EF4-FFF2-40B4-BE49-F238E27FC236}">
-                <a16:creationId xmlns:a16="http://schemas.microsoft.com/office/drawing/2014/main" id="{FE9B5CEB-4423-4641-AC06-872298561EC0}"/>
+                <a16:creationId xmlns:a16="http://schemas.microsoft.com/office/drawing/2014/main" id="{610CD730-2EC2-4024-B892-ED05B7953604}"/>
               </a:ext>
             </a:extLst>
           </p:cNvPr>
@@ -5966,7 +6023,7 @@
           <p:cNvPr id="4" name="">
             <a:extLst xmlns:a="http://schemas.openxmlformats.org/drawingml/2006/main">
               <a:ext uri="{FF2B5EF4-FFF2-40B4-BE49-F238E27FC236}">
-                <a16:creationId xmlns:a16="http://schemas.microsoft.com/office/drawing/2014/main" id="{87B8E17F-AEA8-428E-81EA-727B0CCD1DB5}"/>
+                <a16:creationId xmlns:a16="http://schemas.microsoft.com/office/drawing/2014/main" id="{596D8123-AD14-4F95-A7F9-D130042C31AD}"/>
               </a:ext>
             </a:extLst>
           </p:cNvPr>
@@ -6069,7 +6126,7 @@
           <p:cNvPr id="5" name="">
             <a:extLst xmlns:a="http://schemas.openxmlformats.org/drawingml/2006/main">
               <a:ext uri="{FF2B5EF4-FFF2-40B4-BE49-F238E27FC236}">
-                <a16:creationId xmlns:a16="http://schemas.microsoft.com/office/drawing/2014/main" id="{AABF28C8-9D96-464E-BB00-7B1D8D717AE9}"/>
+                <a16:creationId xmlns:a16="http://schemas.microsoft.com/office/drawing/2014/main" id="{6F0B9FC2-A591-4C08-9559-28DDA28A6AE7}"/>
               </a:ext>
             </a:extLst>
           </p:cNvPr>
@@ -6126,7 +6183,7 @@
           <p:cNvPr id="6" name="">
             <a:extLst xmlns:a="http://schemas.openxmlformats.org/drawingml/2006/main">
               <a:ext uri="{FF2B5EF4-FFF2-40B4-BE49-F238E27FC236}">
-                <a16:creationId xmlns:a16="http://schemas.microsoft.com/office/drawing/2014/main" id="{620F0ED7-9511-45AE-9787-3B4819CB8C1E}"/>
+                <a16:creationId xmlns:a16="http://schemas.microsoft.com/office/drawing/2014/main" id="{049B096A-31C3-4CB4-A0D0-E22FCA9B7D0E}"/>
               </a:ext>
             </a:extLst>
           </p:cNvPr>
@@ -6229,7 +6286,7 @@
           <p:cNvPr id="7" name="">
             <a:extLst xmlns:a="http://schemas.openxmlformats.org/drawingml/2006/main">
               <a:ext uri="{FF2B5EF4-FFF2-40B4-BE49-F238E27FC236}">
-                <a16:creationId xmlns:a16="http://schemas.microsoft.com/office/drawing/2014/main" id="{BC993629-4D82-4A9E-A657-02B27BE0D8D3}"/>
+                <a16:creationId xmlns:a16="http://schemas.microsoft.com/office/drawing/2014/main" id="{CBB94F88-397B-4381-AFAF-A271F2EB2D48}"/>
               </a:ext>
             </a:extLst>
           </p:cNvPr>
@@ -6261,7 +6318,7 @@
           <p:cNvPr id="8" name="">
             <a:extLst xmlns:a="http://schemas.openxmlformats.org/drawingml/2006/main">
               <a:ext uri="{FF2B5EF4-FFF2-40B4-BE49-F238E27FC236}">
-                <a16:creationId xmlns:a16="http://schemas.microsoft.com/office/drawing/2014/main" id="{AB27171B-D048-4CFC-AE5A-F5ECD79DCAF4}"/>
+                <a16:creationId xmlns:a16="http://schemas.microsoft.com/office/drawing/2014/main" id="{762FBE06-C47E-4A08-8E4D-CE21E782C88A}"/>
               </a:ext>
             </a:extLst>
           </p:cNvPr>
@@ -6273,7 +6330,7 @@
         <p:spPr>
           <a:xfrm xmlns:a="http://schemas.openxmlformats.org/drawingml/2006/main">
             <a:off x="609600" y="5410200"/>
-            <a:ext cx="5715000" cy="428625"/>
+            <a:ext cx="10477500" cy="428625"/>
           </a:xfrm>
           <a:prstGeom xmlns:a="http://schemas.openxmlformats.org/drawingml/2006/main" prst="rect">
             <a:avLst/>
@@ -6308,7 +6365,7 @@
                 <a:ea typeface="Arial"/>
                 <a:cs typeface="Arial"/>
               </a:rPr>
-              <a:t>Account login and isolated workspace</a:t>
+              <a:t>Firebase login and an isolated workspace</a:t>
             </a:r>
           </a:p>
         </p:txBody>
@@ -6318,7 +6375,7 @@
           <p:cNvPr id="9" name="">
             <a:extLst xmlns:a="http://schemas.openxmlformats.org/drawingml/2006/main">
               <a:ext uri="{FF2B5EF4-FFF2-40B4-BE49-F238E27FC236}">
-                <a16:creationId xmlns:a16="http://schemas.microsoft.com/office/drawing/2014/main" id="{FA79E28D-4AB3-4739-BD70-73D37B14C2FF}"/>
+                <a16:creationId xmlns:a16="http://schemas.microsoft.com/office/drawing/2014/main" id="{BE7B895F-AB0F-4335-9694-2A65A1DC5F37}"/>
               </a:ext>
             </a:extLst>
           </p:cNvPr>
@@ -6365,7 +6422,7 @@
                 <a:ea typeface="Arial"/>
                 <a:cs typeface="Arial"/>
               </a:rPr>
-              <a:t>Imports and exports / History / Policy configuration</a:t>
+              <a:t>Firestore storage / Cloud Run API / PDF packs and CSV imports</a:t>
             </a:r>
           </a:p>
         </p:txBody>
@@ -6373,7 +6430,7 @@
     </p:spTree>
     <p:extLst>
       <p:ext uri="{BB962C8B-B14F-4D97-AF65-F5344CB8AC3E}">
-        <p14:creationId xmlns:p14="http://schemas.microsoft.com/office/powerpoint/2010/main" val="882276913"/>
+        <p14:creationId xmlns:p14="http://schemas.microsoft.com/office/powerpoint/2010/main" val="697946161"/>
       </p:ext>
     </p:extLst>
   </p:cSld>
@@ -6404,7 +6461,7 @@
           <p:cNvPr id="11" name="">
             <a:extLst xmlns:a="http://schemas.openxmlformats.org/drawingml/2006/main">
               <a:ext uri="{FF2B5EF4-FFF2-40B4-BE49-F238E27FC236}">
-                <a16:creationId xmlns:a16="http://schemas.microsoft.com/office/drawing/2014/main" id="{ED733250-D093-4208-94C0-C86C240BE1A8}"/>
+                <a16:creationId xmlns:a16="http://schemas.microsoft.com/office/drawing/2014/main" id="{0F8E5A83-99F5-4BF4-AE18-E321D9BD7BCF}"/>
               </a:ext>
             </a:extLst>
           </p:cNvPr>
@@ -6461,7 +6518,7 @@
           <p:cNvPr id="2" name="">
             <a:extLst xmlns:a="http://schemas.openxmlformats.org/drawingml/2006/main">
               <a:ext uri="{FF2B5EF4-FFF2-40B4-BE49-F238E27FC236}">
-                <a16:creationId xmlns:a16="http://schemas.microsoft.com/office/drawing/2014/main" id="{34508DC3-7ABD-4792-8CF6-A2B91F9323FB}"/>
+                <a16:creationId xmlns:a16="http://schemas.microsoft.com/office/drawing/2014/main" id="{D7599C0B-4605-4CA5-9D78-0110AD29C10B}"/>
               </a:ext>
             </a:extLst>
           </p:cNvPr>
@@ -6518,7 +6575,7 @@
           <p:cNvPr id="3" name="">
             <a:extLst xmlns:a="http://schemas.openxmlformats.org/drawingml/2006/main">
               <a:ext uri="{FF2B5EF4-FFF2-40B4-BE49-F238E27FC236}">
-                <a16:creationId xmlns:a16="http://schemas.microsoft.com/office/drawing/2014/main" id="{4B34D5D2-1DEB-4E76-8CE8-4FC3220E8621}"/>
+                <a16:creationId xmlns:a16="http://schemas.microsoft.com/office/drawing/2014/main" id="{61894864-C0DB-4045-B7E7-20951168B309}"/>
               </a:ext>
             </a:extLst>
           </p:cNvPr>
@@ -6575,7 +6632,7 @@
           <p:cNvPr id="4" name="">
             <a:extLst xmlns:a="http://schemas.openxmlformats.org/drawingml/2006/main">
               <a:ext uri="{FF2B5EF4-FFF2-40B4-BE49-F238E27FC236}">
-                <a16:creationId xmlns:a16="http://schemas.microsoft.com/office/drawing/2014/main" id="{A7BFBB89-D6C7-4171-A22A-32D019543666}"/>
+                <a16:creationId xmlns:a16="http://schemas.microsoft.com/office/drawing/2014/main" id="{96E025F0-6196-438E-847C-2B5BA611C68C}"/>
               </a:ext>
             </a:extLst>
           </p:cNvPr>
@@ -6632,7 +6689,7 @@
           <p:cNvPr id="5" name="">
             <a:extLst xmlns:a="http://schemas.openxmlformats.org/drawingml/2006/main">
               <a:ext uri="{FF2B5EF4-FFF2-40B4-BE49-F238E27FC236}">
-                <a16:creationId xmlns:a16="http://schemas.microsoft.com/office/drawing/2014/main" id="{F2D9CFE8-3812-4AD9-95A1-AC1DE973E4A4}"/>
+                <a16:creationId xmlns:a16="http://schemas.microsoft.com/office/drawing/2014/main" id="{D2A15657-B6B4-42EB-93EE-DB0CDA63B204}"/>
               </a:ext>
             </a:extLst>
           </p:cNvPr>
@@ -6689,7 +6746,7 @@
           <p:cNvPr id="6" name="">
             <a:extLst xmlns:a="http://schemas.openxmlformats.org/drawingml/2006/main">
               <a:ext uri="{FF2B5EF4-FFF2-40B4-BE49-F238E27FC236}">
-                <a16:creationId xmlns:a16="http://schemas.microsoft.com/office/drawing/2014/main" id="{BA75591F-5811-41BA-89DC-4C055B6B49F3}"/>
+                <a16:creationId xmlns:a16="http://schemas.microsoft.com/office/drawing/2014/main" id="{987EF877-9841-4A02-A230-146192743B89}"/>
               </a:ext>
             </a:extLst>
           </p:cNvPr>
@@ -6746,7 +6803,7 @@
           <p:cNvPr id="7" name="">
             <a:extLst xmlns:a="http://schemas.openxmlformats.org/drawingml/2006/main">
               <a:ext uri="{FF2B5EF4-FFF2-40B4-BE49-F238E27FC236}">
-                <a16:creationId xmlns:a16="http://schemas.microsoft.com/office/drawing/2014/main" id="{20368D87-9A96-4C03-93AD-D2FFFB696C38}"/>
+                <a16:creationId xmlns:a16="http://schemas.microsoft.com/office/drawing/2014/main" id="{C2FAACB4-775C-49F0-B698-242A6BF331E2}"/>
               </a:ext>
             </a:extLst>
           </p:cNvPr>
@@ -6803,7 +6860,7 @@
           <p:cNvPr id="8" name="">
             <a:extLst xmlns:a="http://schemas.openxmlformats.org/drawingml/2006/main">
               <a:ext uri="{FF2B5EF4-FFF2-40B4-BE49-F238E27FC236}">
-                <a16:creationId xmlns:a16="http://schemas.microsoft.com/office/drawing/2014/main" id="{F9C2F152-DA57-42A1-ACB2-8B155A9BE0CE}"/>
+                <a16:creationId xmlns:a16="http://schemas.microsoft.com/office/drawing/2014/main" id="{41EB62D9-24C9-4D01-8306-2324B400F505}"/>
               </a:ext>
             </a:extLst>
           </p:cNvPr>
@@ -6860,7 +6917,7 @@
           <p:cNvPr id="9" name="">
             <a:extLst xmlns:a="http://schemas.openxmlformats.org/drawingml/2006/main">
               <a:ext uri="{FF2B5EF4-FFF2-40B4-BE49-F238E27FC236}">
-                <a16:creationId xmlns:a16="http://schemas.microsoft.com/office/drawing/2014/main" id="{4289889F-D3BB-4714-8453-A669ED43FFA6}"/>
+                <a16:creationId xmlns:a16="http://schemas.microsoft.com/office/drawing/2014/main" id="{17622213-7D3D-41D6-849E-2AF9004364AF}"/>
               </a:ext>
             </a:extLst>
           </p:cNvPr>
@@ -6917,7 +6974,7 @@
           <p:cNvPr id="10" name="">
             <a:extLst xmlns:a="http://schemas.openxmlformats.org/drawingml/2006/main">
               <a:ext uri="{FF2B5EF4-FFF2-40B4-BE49-F238E27FC236}">
-                <a16:creationId xmlns:a16="http://schemas.microsoft.com/office/drawing/2014/main" id="{15907C75-8CCC-45DD-A53F-1C4C4EEDF01C}"/>
+                <a16:creationId xmlns:a16="http://schemas.microsoft.com/office/drawing/2014/main" id="{2638EC68-72BD-464D-A379-376301FB7E0E}"/>
               </a:ext>
             </a:extLst>
           </p:cNvPr>
@@ -6964,7 +7021,7 @@
                 <a:ea typeface="Arial"/>
                 <a:cs typeface="Arial"/>
               </a:rPr>
-              <a:t>At $0.075/minute. Excludes hosting,</a:t>
+              <a:t>At $0.075/minute. Hosting, Firestore,</a:t>
             </a:r>
           </a:p>
           <a:p xmlns:a="http://schemas.openxmlformats.org/drawingml/2006/main">
@@ -6987,7 +7044,7 @@
                 <a:ea typeface="Arial"/>
                 <a:cs typeface="Arial"/>
               </a:rPr>
-              <a:t>support and other operating costs.</a:t>
+              <a:t>support and other costs are additional.</a:t>
             </a:r>
           </a:p>
         </p:txBody>
@@ -6995,7 +7052,7 @@
     </p:spTree>
     <p:extLst>
       <p:ext uri="{BB962C8B-B14F-4D97-AF65-F5344CB8AC3E}">
-        <p14:creationId xmlns:p14="http://schemas.microsoft.com/office/powerpoint/2010/main" val="1888791807"/>
+        <p14:creationId xmlns:p14="http://schemas.microsoft.com/office/powerpoint/2010/main" val="345461259"/>
       </p:ext>
     </p:extLst>
   </p:cSld>
@@ -7026,7 +7083,7 @@
           <p:cNvPr id="10" name="">
             <a:extLst xmlns:a="http://schemas.openxmlformats.org/drawingml/2006/main">
               <a:ext uri="{FF2B5EF4-FFF2-40B4-BE49-F238E27FC236}">
-                <a16:creationId xmlns:a16="http://schemas.microsoft.com/office/drawing/2014/main" id="{9BC400CC-EB12-4788-A146-0F04F3DB39BB}"/>
+                <a16:creationId xmlns:a16="http://schemas.microsoft.com/office/drawing/2014/main" id="{35CF4F92-0A08-4125-A2DA-C7896757B1FF}"/>
               </a:ext>
             </a:extLst>
           </p:cNvPr>
@@ -7083,7 +7140,7 @@
           <p:cNvPr id="2" name="">
             <a:extLst xmlns:a="http://schemas.openxmlformats.org/drawingml/2006/main">
               <a:ext uri="{FF2B5EF4-FFF2-40B4-BE49-F238E27FC236}">
-                <a16:creationId xmlns:a16="http://schemas.microsoft.com/office/drawing/2014/main" id="{76091A04-76BB-412D-9E3A-F72A33CA941F}"/>
+                <a16:creationId xmlns:a16="http://schemas.microsoft.com/office/drawing/2014/main" id="{4F463BB1-8AAB-4686-9B41-82ECF7358481}"/>
               </a:ext>
             </a:extLst>
           </p:cNvPr>
@@ -7140,7 +7197,7 @@
           <p:cNvPr id="3" name="">
             <a:extLst xmlns:a="http://schemas.openxmlformats.org/drawingml/2006/main">
               <a:ext uri="{FF2B5EF4-FFF2-40B4-BE49-F238E27FC236}">
-                <a16:creationId xmlns:a16="http://schemas.microsoft.com/office/drawing/2014/main" id="{13CD8B30-2CB5-4E7B-9C21-4EFE918BCE3E}"/>
+                <a16:creationId xmlns:a16="http://schemas.microsoft.com/office/drawing/2014/main" id="{EB39B831-7DEA-49E1-83EB-53285476E252}"/>
               </a:ext>
             </a:extLst>
           </p:cNvPr>
@@ -7197,7 +7254,7 @@
           <p:cNvPr id="4" name="">
             <a:extLst xmlns:a="http://schemas.openxmlformats.org/drawingml/2006/main">
               <a:ext uri="{FF2B5EF4-FFF2-40B4-BE49-F238E27FC236}">
-                <a16:creationId xmlns:a16="http://schemas.microsoft.com/office/drawing/2014/main" id="{23BDEF85-D0D3-4D59-A5EB-CAE3211A8DF9}"/>
+                <a16:creationId xmlns:a16="http://schemas.microsoft.com/office/drawing/2014/main" id="{46A9B523-22BB-47C9-8C0C-370DC383D5EE}"/>
               </a:ext>
             </a:extLst>
           </p:cNvPr>
@@ -7254,7 +7311,7 @@
           <p:cNvPr id="5" name="">
             <a:extLst xmlns:a="http://schemas.openxmlformats.org/drawingml/2006/main">
               <a:ext uri="{FF2B5EF4-FFF2-40B4-BE49-F238E27FC236}">
-                <a16:creationId xmlns:a16="http://schemas.microsoft.com/office/drawing/2014/main" id="{140DF9A7-F5E7-46CA-8817-C4C7F10EF59D}"/>
+                <a16:creationId xmlns:a16="http://schemas.microsoft.com/office/drawing/2014/main" id="{5195BF64-A2DF-489E-AD99-37F592F38357}"/>
               </a:ext>
             </a:extLst>
           </p:cNvPr>
@@ -7286,7 +7343,7 @@
           <p:cNvPr id="6" name="">
             <a:extLst xmlns:a="http://schemas.openxmlformats.org/drawingml/2006/main">
               <a:ext uri="{FF2B5EF4-FFF2-40B4-BE49-F238E27FC236}">
-                <a16:creationId xmlns:a16="http://schemas.microsoft.com/office/drawing/2014/main" id="{D2C4B1CE-CF01-4158-B57B-F8CCCAD7F2F5}"/>
+                <a16:creationId xmlns:a16="http://schemas.microsoft.com/office/drawing/2014/main" id="{34975708-141E-4207-AB48-653F6E6613EC}"/>
               </a:ext>
             </a:extLst>
           </p:cNvPr>
@@ -7343,7 +7400,7 @@
           <p:cNvPr id="7" name="">
             <a:extLst xmlns:a="http://schemas.openxmlformats.org/drawingml/2006/main">
               <a:ext uri="{FF2B5EF4-FFF2-40B4-BE49-F238E27FC236}">
-                <a16:creationId xmlns:a16="http://schemas.microsoft.com/office/drawing/2014/main" id="{2EBF93E7-57E6-4F98-9228-913A3D90E58C}"/>
+                <a16:creationId xmlns:a16="http://schemas.microsoft.com/office/drawing/2014/main" id="{918E6D04-1862-49DF-9608-2702AAC0C27B}"/>
               </a:ext>
             </a:extLst>
           </p:cNvPr>
@@ -7400,7 +7457,7 @@
           <p:cNvPr id="8" name="">
             <a:extLst xmlns:a="http://schemas.openxmlformats.org/drawingml/2006/main">
               <a:ext uri="{FF2B5EF4-FFF2-40B4-BE49-F238E27FC236}">
-                <a16:creationId xmlns:a16="http://schemas.microsoft.com/office/drawing/2014/main" id="{E7CBE376-4FEC-4D3D-BFF4-24DE7C281BDA}"/>
+                <a16:creationId xmlns:a16="http://schemas.microsoft.com/office/drawing/2014/main" id="{900C826A-B199-4AFB-9A23-FE68B65A2BA1}"/>
               </a:ext>
             </a:extLst>
           </p:cNvPr>
@@ -7457,7 +7514,7 @@
           <p:cNvPr id="9" name="">
             <a:extLst xmlns:a="http://schemas.openxmlformats.org/drawingml/2006/main">
               <a:ext uri="{FF2B5EF4-FFF2-40B4-BE49-F238E27FC236}">
-                <a16:creationId xmlns:a16="http://schemas.microsoft.com/office/drawing/2014/main" id="{F5D63CF6-1B89-4DA5-AD6E-1716677DF15E}"/>
+                <a16:creationId xmlns:a16="http://schemas.microsoft.com/office/drawing/2014/main" id="{8471AFBF-1AD3-489B-9DBE-52D28E255613}"/>
               </a:ext>
             </a:extLst>
           </p:cNvPr>
@@ -7512,7 +7569,7 @@
     </p:spTree>
     <p:extLst>
       <p:ext uri="{BB962C8B-B14F-4D97-AF65-F5344CB8AC3E}">
-        <p14:creationId xmlns:p14="http://schemas.microsoft.com/office/powerpoint/2010/main" val="1040219891"/>
+        <p14:creationId xmlns:p14="http://schemas.microsoft.com/office/powerpoint/2010/main" val="1484468170"/>
       </p:ext>
     </p:extLst>
   </p:cSld>
@@ -7543,7 +7600,7 @@
           <p:cNvPr id="14" name="">
             <a:extLst xmlns:a="http://schemas.openxmlformats.org/drawingml/2006/main">
               <a:ext uri="{FF2B5EF4-FFF2-40B4-BE49-F238E27FC236}">
-                <a16:creationId xmlns:a16="http://schemas.microsoft.com/office/drawing/2014/main" id="{4A0F2BBC-85C0-4981-AD9B-2ADA3D249E61}"/>
+                <a16:creationId xmlns:a16="http://schemas.microsoft.com/office/drawing/2014/main" id="{DA322B1D-3BBA-4619-B505-AE62AEDA4B36}"/>
               </a:ext>
             </a:extLst>
           </p:cNvPr>
@@ -7600,7 +7657,7 @@
           <p:cNvPr id="2" name="">
             <a:extLst xmlns:a="http://schemas.openxmlformats.org/drawingml/2006/main">
               <a:ext uri="{FF2B5EF4-FFF2-40B4-BE49-F238E27FC236}">
-                <a16:creationId xmlns:a16="http://schemas.microsoft.com/office/drawing/2014/main" id="{618E7351-2B2D-43F8-A973-791CB01CE93C}"/>
+                <a16:creationId xmlns:a16="http://schemas.microsoft.com/office/drawing/2014/main" id="{A9537353-F5FE-4FE8-BB45-CB989D234BBD}"/>
               </a:ext>
             </a:extLst>
           </p:cNvPr>
@@ -7657,7 +7714,7 @@
           <p:cNvPr id="3" name="">
             <a:extLst xmlns:a="http://schemas.openxmlformats.org/drawingml/2006/main">
               <a:ext uri="{FF2B5EF4-FFF2-40B4-BE49-F238E27FC236}">
-                <a16:creationId xmlns:a16="http://schemas.microsoft.com/office/drawing/2014/main" id="{7F93673B-8E53-442E-B372-45FD93B33B41}"/>
+                <a16:creationId xmlns:a16="http://schemas.microsoft.com/office/drawing/2014/main" id="{E439FB46-9B44-4B38-BB18-923EB1BF4EC5}"/>
               </a:ext>
             </a:extLst>
           </p:cNvPr>
@@ -7714,7 +7771,7 @@
           <p:cNvPr id="4" name="">
             <a:extLst xmlns:a="http://schemas.openxmlformats.org/drawingml/2006/main">
               <a:ext uri="{FF2B5EF4-FFF2-40B4-BE49-F238E27FC236}">
-                <a16:creationId xmlns:a16="http://schemas.microsoft.com/office/drawing/2014/main" id="{6FA1C0AB-30C1-47BC-8448-5AFD77A58C27}"/>
+                <a16:creationId xmlns:a16="http://schemas.microsoft.com/office/drawing/2014/main" id="{CDEEA94C-3427-4258-BC5B-329C0AC6026B}"/>
               </a:ext>
             </a:extLst>
           </p:cNvPr>
@@ -7771,7 +7828,7 @@
           <p:cNvPr id="5" name="">
             <a:extLst xmlns:a="http://schemas.openxmlformats.org/drawingml/2006/main">
               <a:ext uri="{FF2B5EF4-FFF2-40B4-BE49-F238E27FC236}">
-                <a16:creationId xmlns:a16="http://schemas.microsoft.com/office/drawing/2014/main" id="{D13177FE-33FC-47D8-80CC-75CD75AE242B}"/>
+                <a16:creationId xmlns:a16="http://schemas.microsoft.com/office/drawing/2014/main" id="{8BFE7776-5915-40FB-A02B-E1F6946AEE84}"/>
               </a:ext>
             </a:extLst>
           </p:cNvPr>
@@ -7828,7 +7885,7 @@
           <p:cNvPr id="6" name="">
             <a:extLst xmlns:a="http://schemas.openxmlformats.org/drawingml/2006/main">
               <a:ext uri="{FF2B5EF4-FFF2-40B4-BE49-F238E27FC236}">
-                <a16:creationId xmlns:a16="http://schemas.microsoft.com/office/drawing/2014/main" id="{07A2F1F5-B62F-4E66-BFE4-57399D359BE5}"/>
+                <a16:creationId xmlns:a16="http://schemas.microsoft.com/office/drawing/2014/main" id="{1B07D983-78A5-4F7C-98DA-7BDFCDBBACFE}"/>
               </a:ext>
             </a:extLst>
           </p:cNvPr>
@@ -7885,7 +7942,7 @@
           <p:cNvPr id="7" name="">
             <a:extLst xmlns:a="http://schemas.openxmlformats.org/drawingml/2006/main">
               <a:ext uri="{FF2B5EF4-FFF2-40B4-BE49-F238E27FC236}">
-                <a16:creationId xmlns:a16="http://schemas.microsoft.com/office/drawing/2014/main" id="{F33C2FEF-D846-4A61-BDCB-92A35B51F00E}"/>
+                <a16:creationId xmlns:a16="http://schemas.microsoft.com/office/drawing/2014/main" id="{4C6BD87D-72D3-476A-9032-59BDB08FAE49}"/>
               </a:ext>
             </a:extLst>
           </p:cNvPr>
@@ -7942,7 +7999,7 @@
           <p:cNvPr id="8" name="">
             <a:extLst xmlns:a="http://schemas.openxmlformats.org/drawingml/2006/main">
               <a:ext uri="{FF2B5EF4-FFF2-40B4-BE49-F238E27FC236}">
-                <a16:creationId xmlns:a16="http://schemas.microsoft.com/office/drawing/2014/main" id="{BEA4479A-E1E9-4DBD-8724-86588E5F76B9}"/>
+                <a16:creationId xmlns:a16="http://schemas.microsoft.com/office/drawing/2014/main" id="{DA8454C1-48F4-4401-9D99-097C92CF5054}"/>
               </a:ext>
             </a:extLst>
           </p:cNvPr>
@@ -7989,7 +8046,7 @@
                 <a:ea typeface="Arial"/>
                 <a:cs typeface="Arial"/>
               </a:rPr>
-              <a:t>Follow real returns</a:t>
+              <a:t>Compare against a short form</a:t>
             </a:r>
           </a:p>
         </p:txBody>
@@ -7999,7 +8056,7 @@
           <p:cNvPr id="9" name="">
             <a:extLst xmlns:a="http://schemas.openxmlformats.org/drawingml/2006/main">
               <a:ext uri="{FF2B5EF4-FFF2-40B4-BE49-F238E27FC236}">
-                <a16:creationId xmlns:a16="http://schemas.microsoft.com/office/drawing/2014/main" id="{B8C501F2-5A74-409F-8262-A039844711A2}"/>
+                <a16:creationId xmlns:a16="http://schemas.microsoft.com/office/drawing/2014/main" id="{4142B660-FACC-414B-8F8D-4752264C0E51}"/>
               </a:ext>
             </a:extLst>
           </p:cNvPr>
@@ -8046,7 +8103,7 @@
                 <a:ea typeface="Arial"/>
                 <a:cs typeface="Arial"/>
               </a:rPr>
-              <a:t>Measure approved packs, dispatches, and exceptions.</a:t>
+              <a:t>Measure time at the bench and the work to import records.</a:t>
             </a:r>
           </a:p>
         </p:txBody>
@@ -8056,7 +8113,7 @@
           <p:cNvPr id="10" name="">
             <a:extLst xmlns:a="http://schemas.openxmlformats.org/drawingml/2006/main">
               <a:ext uri="{FF2B5EF4-FFF2-40B4-BE49-F238E27FC236}">
-                <a16:creationId xmlns:a16="http://schemas.microsoft.com/office/drawing/2014/main" id="{D3FB036E-22EC-49D2-B0CF-8CFA7797DFF7}"/>
+                <a16:creationId xmlns:a16="http://schemas.microsoft.com/office/drawing/2014/main" id="{E83B511E-A504-4735-86A3-1AEA09599195}"/>
               </a:ext>
             </a:extLst>
           </p:cNvPr>
@@ -8113,7 +8170,7 @@
           <p:cNvPr id="11" name="">
             <a:extLst xmlns:a="http://schemas.openxmlformats.org/drawingml/2006/main">
               <a:ext uri="{FF2B5EF4-FFF2-40B4-BE49-F238E27FC236}">
-                <a16:creationId xmlns:a16="http://schemas.microsoft.com/office/drawing/2014/main" id="{9EB347C9-43B8-4F52-A410-BF43DACD1D5F}"/>
+                <a16:creationId xmlns:a16="http://schemas.microsoft.com/office/drawing/2014/main" id="{932DD049-AF11-4A24-BC0A-74A3F573C400}"/>
               </a:ext>
             </a:extLst>
           </p:cNvPr>
@@ -8170,7 +8227,7 @@
           <p:cNvPr id="12" name="">
             <a:extLst xmlns:a="http://schemas.openxmlformats.org/drawingml/2006/main">
               <a:ext uri="{FF2B5EF4-FFF2-40B4-BE49-F238E27FC236}">
-                <a16:creationId xmlns:a16="http://schemas.microsoft.com/office/drawing/2014/main" id="{56ADAE34-4EB8-48F0-8362-69EB3CA33408}"/>
+                <a16:creationId xmlns:a16="http://schemas.microsoft.com/office/drawing/2014/main" id="{C6F0E1ED-4695-4AEB-87B6-2A57026AEF4C}"/>
               </a:ext>
             </a:extLst>
           </p:cNvPr>
@@ -8227,7 +8284,7 @@
           <p:cNvPr id="13" name="">
             <a:extLst xmlns:a="http://schemas.openxmlformats.org/drawingml/2006/main">
               <a:ext uri="{FF2B5EF4-FFF2-40B4-BE49-F238E27FC236}">
-                <a16:creationId xmlns:a16="http://schemas.microsoft.com/office/drawing/2014/main" id="{18F1CC6C-BBB0-4B41-8625-909AE603C394}"/>
+                <a16:creationId xmlns:a16="http://schemas.microsoft.com/office/drawing/2014/main" id="{BC04BF90-0AA0-44F1-BB13-0BEE1B30CF06}"/>
               </a:ext>
             </a:extLst>
           </p:cNvPr>
@@ -8239,7 +8296,7 @@
         <p:spPr>
           <a:xfrm xmlns:a="http://schemas.openxmlformats.org/drawingml/2006/main">
             <a:off x="609600" y="6200775"/>
-            <a:ext cx="6477000" cy="361950"/>
+            <a:ext cx="10287000" cy="361950"/>
           </a:xfrm>
           <a:prstGeom xmlns:a="http://schemas.openxmlformats.org/drawingml/2006/main" prst="rect">
             <a:avLst/>
@@ -8274,7 +8331,7 @@
                 <a:ea typeface="Arial"/>
                 <a:cs typeface="Arial"/>
               </a:rPr>
-              <a:t>Benchback</a:t>
+              <a:t>Try Benchback: benchback-ai.web.app</a:t>
             </a:r>
           </a:p>
         </p:txBody>
@@ -8282,7 +8339,7 @@
     </p:spTree>
     <p:extLst>
       <p:ext uri="{BB962C8B-B14F-4D97-AF65-F5344CB8AC3E}">
-        <p14:creationId xmlns:p14="http://schemas.microsoft.com/office/powerpoint/2010/main" val="661861587"/>
+        <p14:creationId xmlns:p14="http://schemas.microsoft.com/office/powerpoint/2010/main" val="1200710422"/>
       </p:ext>
     </p:extLst>
   </p:cSld>

</xml_diff>